<commit_message>
Lapozó rendszer elkészülése, ppt finomhangolása és ezzel a végleges projekt befejezése
</commit_message>
<xml_diff>
--- a/nepesseg2025.pptx
+++ b/nepesseg2025.pptx
@@ -10,7 +10,8 @@
     <p:sldId id="257" r:id="rId4"/>
     <p:sldId id="258" r:id="rId5"/>
     <p:sldId id="259" r:id="rId6"/>
-    <p:sldId id="260" r:id="rId7"/>
+    <p:sldId id="262" r:id="rId7"/>
+    <p:sldId id="260" r:id="rId8"/>
   </p:sldIdLst>
   <p:sldSz cx="12192000" cy="6858000"/>
   <p:notesSz cx="6858000" cy="9144000"/>
@@ -875,13 +876,13 @@
       <dgm:prSet phldrT="[Szöveg]"/>
       <dgm:spPr>
         <a:solidFill>
-          <a:schemeClr val="bg2">
-            <a:lumMod val="25000"/>
+          <a:schemeClr val="bg1">
+            <a:lumMod val="75000"/>
           </a:schemeClr>
         </a:solidFill>
         <a:ln>
           <a:solidFill>
-            <a:schemeClr val="bg1"/>
+            <a:schemeClr val="tx1"/>
           </a:solidFill>
         </a:ln>
       </dgm:spPr>
@@ -890,7 +891,12 @@
         <a:lstStyle/>
         <a:p>
           <a:r>
-            <a:rPr lang="hu-HU" dirty="0"/>
+            <a:rPr lang="hu-HU" dirty="0">
+              <a:solidFill>
+                <a:schemeClr val="tx1"/>
+              </a:solidFill>
+              <a:latin typeface="Arial Black" panose="020B0A04020102020204" pitchFamily="34" charset="0"/>
+            </a:rPr>
             <a:t>Megyekód</a:t>
           </a:r>
         </a:p>
@@ -911,14 +917,13 @@
       <dgm:prSet/>
       <dgm:spPr>
         <a:solidFill>
-          <a:schemeClr val="tx1">
+          <a:schemeClr val="bg1">
             <a:lumMod val="75000"/>
-            <a:lumOff val="25000"/>
           </a:schemeClr>
         </a:solidFill>
         <a:ln>
           <a:solidFill>
-            <a:schemeClr val="bg1"/>
+            <a:schemeClr val="tx1"/>
           </a:solidFill>
         </a:ln>
       </dgm:spPr>
@@ -934,13 +939,13 @@
       <dgm:prSet phldrT="[Szöveg]"/>
       <dgm:spPr>
         <a:solidFill>
-          <a:schemeClr val="bg2">
-            <a:lumMod val="25000"/>
+          <a:schemeClr val="bg1">
+            <a:lumMod val="75000"/>
           </a:schemeClr>
         </a:solidFill>
         <a:ln>
           <a:solidFill>
-            <a:schemeClr val="bg1"/>
+            <a:schemeClr val="tx1"/>
           </a:solidFill>
         </a:ln>
       </dgm:spPr>
@@ -949,7 +954,12 @@
         <a:lstStyle/>
         <a:p>
           <a:r>
-            <a:rPr lang="hu-HU" dirty="0"/>
+            <a:rPr lang="hu-HU" dirty="0">
+              <a:solidFill>
+                <a:schemeClr val="tx1"/>
+              </a:solidFill>
+              <a:latin typeface="Arial Black" panose="020B0A04020102020204" pitchFamily="34" charset="0"/>
+            </a:rPr>
             <a:t>Települések száma</a:t>
           </a:r>
         </a:p>
@@ -970,14 +980,13 @@
       <dgm:prSet/>
       <dgm:spPr>
         <a:solidFill>
-          <a:schemeClr val="tx1">
+          <a:schemeClr val="bg1">
             <a:lumMod val="75000"/>
-            <a:lumOff val="25000"/>
           </a:schemeClr>
         </a:solidFill>
         <a:ln>
           <a:solidFill>
-            <a:schemeClr val="bg1"/>
+            <a:schemeClr val="tx1"/>
           </a:solidFill>
         </a:ln>
       </dgm:spPr>
@@ -993,13 +1002,13 @@
       <dgm:prSet phldrT="[Szöveg]"/>
       <dgm:spPr>
         <a:solidFill>
-          <a:schemeClr val="bg2">
-            <a:lumMod val="25000"/>
+          <a:schemeClr val="bg1">
+            <a:lumMod val="75000"/>
           </a:schemeClr>
         </a:solidFill>
         <a:ln>
           <a:solidFill>
-            <a:schemeClr val="bg1"/>
+            <a:schemeClr val="tx1"/>
           </a:solidFill>
         </a:ln>
       </dgm:spPr>
@@ -1008,8 +1017,26 @@
         <a:lstStyle/>
         <a:p>
           <a:r>
+            <a:rPr lang="hu-HU" dirty="0">
+              <a:solidFill>
+                <a:schemeClr val="tx1"/>
+              </a:solidFill>
+              <a:latin typeface="Arial Black" panose="020B0A04020102020204" pitchFamily="34" charset="0"/>
+            </a:rPr>
+            <a:t>Lakosok</a:t>
+          </a:r>
+          <a:r>
             <a:rPr lang="hu-HU" dirty="0"/>
-            <a:t>Lakosok száma</a:t>
+            <a:t> </a:t>
+          </a:r>
+          <a:r>
+            <a:rPr lang="hu-HU" dirty="0">
+              <a:solidFill>
+                <a:schemeClr val="tx1"/>
+              </a:solidFill>
+              <a:latin typeface="Arial Black" panose="020B0A04020102020204" pitchFamily="34" charset="0"/>
+            </a:rPr>
+            <a:t>száma</a:t>
           </a:r>
         </a:p>
       </dgm:t>
@@ -1140,13 +1167,13 @@
           </a:avLst>
         </a:prstGeom>
         <a:solidFill>
-          <a:schemeClr val="bg2">
-            <a:lumMod val="25000"/>
+          <a:schemeClr val="bg1">
+            <a:lumMod val="75000"/>
           </a:schemeClr>
         </a:solidFill>
         <a:ln w="12700" cap="flat" cmpd="sng" algn="ctr">
           <a:solidFill>
-            <a:schemeClr val="bg1"/>
+            <a:schemeClr val="tx1"/>
           </a:solidFill>
           <a:prstDash val="solid"/>
           <a:miter lim="800000"/>
@@ -1168,12 +1195,12 @@
         </a:fontRef>
       </dsp:style>
       <dsp:txBody>
-        <a:bodyPr spcFirstLastPara="0" vert="horz" wrap="square" lIns="99060" tIns="99060" rIns="99060" bIns="99060" numCol="1" spcCol="1270" anchor="ctr" anchorCtr="0">
+        <a:bodyPr spcFirstLastPara="0" vert="horz" wrap="square" lIns="72390" tIns="72390" rIns="72390" bIns="72390" numCol="1" spcCol="1270" anchor="ctr" anchorCtr="0">
           <a:noAutofit/>
         </a:bodyPr>
         <a:lstStyle/>
         <a:p>
-          <a:pPr marL="0" lvl="0" indent="0" algn="ctr" defTabSz="1155700">
+          <a:pPr marL="0" lvl="0" indent="0" algn="ctr" defTabSz="844550">
             <a:lnSpc>
               <a:spcPct val="90000"/>
             </a:lnSpc>
@@ -1186,7 +1213,12 @@
             <a:buNone/>
           </a:pPr>
           <a:r>
-            <a:rPr lang="hu-HU" sz="2600" kern="1200" dirty="0"/>
+            <a:rPr lang="hu-HU" sz="1900" kern="1200" dirty="0">
+              <a:solidFill>
+                <a:schemeClr val="tx1"/>
+              </a:solidFill>
+              <a:latin typeface="Arial Black" panose="020B0A04020102020204" pitchFamily="34" charset="0"/>
+            </a:rPr>
             <a:t>Megyekód</a:t>
           </a:r>
         </a:p>
@@ -1213,14 +1245,13 @@
           </a:avLst>
         </a:prstGeom>
         <a:solidFill>
-          <a:schemeClr val="tx1">
+          <a:schemeClr val="bg1">
             <a:lumMod val="75000"/>
-            <a:lumOff val="25000"/>
           </a:schemeClr>
         </a:solidFill>
         <a:ln>
           <a:solidFill>
-            <a:schemeClr val="bg1"/>
+            <a:schemeClr val="tx1"/>
           </a:solidFill>
         </a:ln>
         <a:effectLst/>
@@ -1245,7 +1276,7 @@
         </a:bodyPr>
         <a:lstStyle/>
         <a:p>
-          <a:pPr marL="0" lvl="0" indent="0" algn="ctr" defTabSz="889000">
+          <a:pPr marL="0" lvl="0" indent="0" algn="ctr" defTabSz="666750">
             <a:lnSpc>
               <a:spcPct val="90000"/>
             </a:lnSpc>
@@ -1257,7 +1288,7 @@
             </a:spcAft>
             <a:buNone/>
           </a:pPr>
-          <a:endParaRPr lang="hu-HU" sz="2000" kern="1200"/>
+          <a:endParaRPr lang="hu-HU" sz="1500" kern="1200"/>
         </a:p>
       </dsp:txBody>
       <dsp:txXfrm>
@@ -1281,13 +1312,13 @@
           </a:avLst>
         </a:prstGeom>
         <a:solidFill>
-          <a:schemeClr val="bg2">
-            <a:lumMod val="25000"/>
+          <a:schemeClr val="bg1">
+            <a:lumMod val="75000"/>
           </a:schemeClr>
         </a:solidFill>
         <a:ln w="12700" cap="flat" cmpd="sng" algn="ctr">
           <a:solidFill>
-            <a:schemeClr val="bg1"/>
+            <a:schemeClr val="tx1"/>
           </a:solidFill>
           <a:prstDash val="solid"/>
           <a:miter lim="800000"/>
@@ -1309,12 +1340,12 @@
         </a:fontRef>
       </dsp:style>
       <dsp:txBody>
-        <a:bodyPr spcFirstLastPara="0" vert="horz" wrap="square" lIns="99060" tIns="99060" rIns="99060" bIns="99060" numCol="1" spcCol="1270" anchor="ctr" anchorCtr="0">
+        <a:bodyPr spcFirstLastPara="0" vert="horz" wrap="square" lIns="72390" tIns="72390" rIns="72390" bIns="72390" numCol="1" spcCol="1270" anchor="ctr" anchorCtr="0">
           <a:noAutofit/>
         </a:bodyPr>
         <a:lstStyle/>
         <a:p>
-          <a:pPr marL="0" lvl="0" indent="0" algn="ctr" defTabSz="1155700">
+          <a:pPr marL="0" lvl="0" indent="0" algn="ctr" defTabSz="844550">
             <a:lnSpc>
               <a:spcPct val="90000"/>
             </a:lnSpc>
@@ -1327,7 +1358,12 @@
             <a:buNone/>
           </a:pPr>
           <a:r>
-            <a:rPr lang="hu-HU" sz="2600" kern="1200" dirty="0"/>
+            <a:rPr lang="hu-HU" sz="1900" kern="1200" dirty="0">
+              <a:solidFill>
+                <a:schemeClr val="tx1"/>
+              </a:solidFill>
+              <a:latin typeface="Arial Black" panose="020B0A04020102020204" pitchFamily="34" charset="0"/>
+            </a:rPr>
             <a:t>Települések száma</a:t>
           </a:r>
         </a:p>
@@ -1354,14 +1390,13 @@
           </a:avLst>
         </a:prstGeom>
         <a:solidFill>
-          <a:schemeClr val="tx1">
+          <a:schemeClr val="bg1">
             <a:lumMod val="75000"/>
-            <a:lumOff val="25000"/>
           </a:schemeClr>
         </a:solidFill>
         <a:ln>
           <a:solidFill>
-            <a:schemeClr val="bg1"/>
+            <a:schemeClr val="tx1"/>
           </a:solidFill>
         </a:ln>
         <a:effectLst/>
@@ -1386,7 +1421,7 @@
         </a:bodyPr>
         <a:lstStyle/>
         <a:p>
-          <a:pPr marL="0" lvl="0" indent="0" algn="ctr" defTabSz="889000">
+          <a:pPr marL="0" lvl="0" indent="0" algn="ctr" defTabSz="666750">
             <a:lnSpc>
               <a:spcPct val="90000"/>
             </a:lnSpc>
@@ -1398,7 +1433,7 @@
             </a:spcAft>
             <a:buNone/>
           </a:pPr>
-          <a:endParaRPr lang="hu-HU" sz="2000" kern="1200"/>
+          <a:endParaRPr lang="hu-HU" sz="1500" kern="1200"/>
         </a:p>
       </dsp:txBody>
       <dsp:txXfrm>
@@ -1422,13 +1457,13 @@
           </a:avLst>
         </a:prstGeom>
         <a:solidFill>
-          <a:schemeClr val="bg2">
-            <a:lumMod val="25000"/>
+          <a:schemeClr val="bg1">
+            <a:lumMod val="75000"/>
           </a:schemeClr>
         </a:solidFill>
         <a:ln w="12700" cap="flat" cmpd="sng" algn="ctr">
           <a:solidFill>
-            <a:schemeClr val="bg1"/>
+            <a:schemeClr val="tx1"/>
           </a:solidFill>
           <a:prstDash val="solid"/>
           <a:miter lim="800000"/>
@@ -1450,12 +1485,12 @@
         </a:fontRef>
       </dsp:style>
       <dsp:txBody>
-        <a:bodyPr spcFirstLastPara="0" vert="horz" wrap="square" lIns="99060" tIns="99060" rIns="99060" bIns="99060" numCol="1" spcCol="1270" anchor="ctr" anchorCtr="0">
+        <a:bodyPr spcFirstLastPara="0" vert="horz" wrap="square" lIns="72390" tIns="72390" rIns="72390" bIns="72390" numCol="1" spcCol="1270" anchor="ctr" anchorCtr="0">
           <a:noAutofit/>
         </a:bodyPr>
         <a:lstStyle/>
         <a:p>
-          <a:pPr marL="0" lvl="0" indent="0" algn="ctr" defTabSz="1155700">
+          <a:pPr marL="0" lvl="0" indent="0" algn="ctr" defTabSz="844550">
             <a:lnSpc>
               <a:spcPct val="90000"/>
             </a:lnSpc>
@@ -1468,8 +1503,26 @@
             <a:buNone/>
           </a:pPr>
           <a:r>
-            <a:rPr lang="hu-HU" sz="2600" kern="1200" dirty="0"/>
-            <a:t>Lakosok száma</a:t>
+            <a:rPr lang="hu-HU" sz="1900" kern="1200" dirty="0">
+              <a:solidFill>
+                <a:schemeClr val="tx1"/>
+              </a:solidFill>
+              <a:latin typeface="Arial Black" panose="020B0A04020102020204" pitchFamily="34" charset="0"/>
+            </a:rPr>
+            <a:t>Lakosok</a:t>
+          </a:r>
+          <a:r>
+            <a:rPr lang="hu-HU" sz="1900" kern="1200" dirty="0"/>
+            <a:t> </a:t>
+          </a:r>
+          <a:r>
+            <a:rPr lang="hu-HU" sz="1900" kern="1200" dirty="0">
+              <a:solidFill>
+                <a:schemeClr val="tx1"/>
+              </a:solidFill>
+              <a:latin typeface="Arial Black" panose="020B0A04020102020204" pitchFamily="34" charset="0"/>
+            </a:rPr>
+            <a:t>száma</a:t>
           </a:r>
         </a:p>
       </dsp:txBody>
@@ -2809,7 +2862,7 @@
           <a:p>
             <a:fld id="{2FCEDCD4-395B-4C9B-BA6D-AA0439BDF8B8}" type="datetimeFigureOut">
               <a:rPr lang="hu-HU" smtClean="0"/>
-              <a:t>2026. 09. 15.</a:t>
+              <a:t>2026. 09. 17.</a:t>
             </a:fld>
             <a:endParaRPr lang="hu-HU"/>
           </a:p>
@@ -3007,7 +3060,7 @@
           <a:p>
             <a:fld id="{2FCEDCD4-395B-4C9B-BA6D-AA0439BDF8B8}" type="datetimeFigureOut">
               <a:rPr lang="hu-HU" smtClean="0"/>
-              <a:t>2026. 09. 15.</a:t>
+              <a:t>2026. 09. 17.</a:t>
             </a:fld>
             <a:endParaRPr lang="hu-HU"/>
           </a:p>
@@ -3215,7 +3268,7 @@
           <a:p>
             <a:fld id="{2FCEDCD4-395B-4C9B-BA6D-AA0439BDF8B8}" type="datetimeFigureOut">
               <a:rPr lang="hu-HU" smtClean="0"/>
-              <a:t>2026. 09. 15.</a:t>
+              <a:t>2026. 09. 17.</a:t>
             </a:fld>
             <a:endParaRPr lang="hu-HU"/>
           </a:p>
@@ -3413,7 +3466,7 @@
           <a:p>
             <a:fld id="{2FCEDCD4-395B-4C9B-BA6D-AA0439BDF8B8}" type="datetimeFigureOut">
               <a:rPr lang="hu-HU" smtClean="0"/>
-              <a:t>2026. 09. 15.</a:t>
+              <a:t>2026. 09. 17.</a:t>
             </a:fld>
             <a:endParaRPr lang="hu-HU"/>
           </a:p>
@@ -3688,7 +3741,7 @@
           <a:p>
             <a:fld id="{2FCEDCD4-395B-4C9B-BA6D-AA0439BDF8B8}" type="datetimeFigureOut">
               <a:rPr lang="hu-HU" smtClean="0"/>
-              <a:t>2026. 09. 15.</a:t>
+              <a:t>2026. 09. 17.</a:t>
             </a:fld>
             <a:endParaRPr lang="hu-HU"/>
           </a:p>
@@ -3953,7 +4006,7 @@
           <a:p>
             <a:fld id="{2FCEDCD4-395B-4C9B-BA6D-AA0439BDF8B8}" type="datetimeFigureOut">
               <a:rPr lang="hu-HU" smtClean="0"/>
-              <a:t>2026. 09. 15.</a:t>
+              <a:t>2026. 09. 17.</a:t>
             </a:fld>
             <a:endParaRPr lang="hu-HU"/>
           </a:p>
@@ -4365,7 +4418,7 @@
           <a:p>
             <a:fld id="{2FCEDCD4-395B-4C9B-BA6D-AA0439BDF8B8}" type="datetimeFigureOut">
               <a:rPr lang="hu-HU" smtClean="0"/>
-              <a:t>2026. 09. 15.</a:t>
+              <a:t>2026. 09. 17.</a:t>
             </a:fld>
             <a:endParaRPr lang="hu-HU"/>
           </a:p>
@@ -4506,7 +4559,7 @@
           <a:p>
             <a:fld id="{2FCEDCD4-395B-4C9B-BA6D-AA0439BDF8B8}" type="datetimeFigureOut">
               <a:rPr lang="hu-HU" smtClean="0"/>
-              <a:t>2026. 09. 15.</a:t>
+              <a:t>2026. 09. 17.</a:t>
             </a:fld>
             <a:endParaRPr lang="hu-HU"/>
           </a:p>
@@ -4619,7 +4672,7 @@
           <a:p>
             <a:fld id="{2FCEDCD4-395B-4C9B-BA6D-AA0439BDF8B8}" type="datetimeFigureOut">
               <a:rPr lang="hu-HU" smtClean="0"/>
-              <a:t>2026. 09. 15.</a:t>
+              <a:t>2026. 09. 17.</a:t>
             </a:fld>
             <a:endParaRPr lang="hu-HU"/>
           </a:p>
@@ -4930,7 +4983,7 @@
           <a:p>
             <a:fld id="{2FCEDCD4-395B-4C9B-BA6D-AA0439BDF8B8}" type="datetimeFigureOut">
               <a:rPr lang="hu-HU" smtClean="0"/>
-              <a:t>2026. 09. 15.</a:t>
+              <a:t>2026. 09. 17.</a:t>
             </a:fld>
             <a:endParaRPr lang="hu-HU"/>
           </a:p>
@@ -5218,7 +5271,7 @@
           <a:p>
             <a:fld id="{2FCEDCD4-395B-4C9B-BA6D-AA0439BDF8B8}" type="datetimeFigureOut">
               <a:rPr lang="hu-HU" smtClean="0"/>
-              <a:t>2026. 09. 15.</a:t>
+              <a:t>2026. 09. 17.</a:t>
             </a:fld>
             <a:endParaRPr lang="hu-HU"/>
           </a:p>
@@ -5459,7 +5512,7 @@
           <a:p>
             <a:fld id="{2FCEDCD4-395B-4C9B-BA6D-AA0439BDF8B8}" type="datetimeFigureOut">
               <a:rPr lang="hu-HU" smtClean="0"/>
-              <a:t>2026. 09. 15.</a:t>
+              <a:t>2026. 09. 17.</a:t>
             </a:fld>
             <a:endParaRPr lang="hu-HU"/>
           </a:p>
@@ -6247,6 +6300,108 @@
           <a:chExt cx="0" cy="0"/>
         </a:xfrm>
       </p:grpSpPr>
+      <p:sp>
+        <p:nvSpPr>
+          <p:cNvPr id="3" name="Téglalap 2">
+            <a:extLst>
+              <a:ext uri="{FF2B5EF4-FFF2-40B4-BE49-F238E27FC236}">
+                <a16:creationId xmlns:a16="http://schemas.microsoft.com/office/drawing/2014/main" id="{8009D334-2AB9-A3A2-403C-7E5555AFC45F}"/>
+              </a:ext>
+            </a:extLst>
+          </p:cNvPr>
+          <p:cNvSpPr/>
+          <p:nvPr/>
+        </p:nvSpPr>
+        <p:spPr>
+          <a:xfrm>
+            <a:off x="5202302" y="5093037"/>
+            <a:ext cx="6128334" cy="717663"/>
+          </a:xfrm>
+          <a:prstGeom prst="rect">
+            <a:avLst/>
+          </a:prstGeom>
+          <a:solidFill>
+            <a:schemeClr val="bg1">
+              <a:lumMod val="75000"/>
+            </a:schemeClr>
+          </a:solidFill>
+        </p:spPr>
+        <p:style>
+          <a:lnRef idx="2">
+            <a:schemeClr val="accent1">
+              <a:shade val="15000"/>
+            </a:schemeClr>
+          </a:lnRef>
+          <a:fillRef idx="1">
+            <a:schemeClr val="accent1"/>
+          </a:fillRef>
+          <a:effectRef idx="0">
+            <a:schemeClr val="accent1"/>
+          </a:effectRef>
+          <a:fontRef idx="minor">
+            <a:schemeClr val="lt1"/>
+          </a:fontRef>
+        </p:style>
+        <p:txBody>
+          <a:bodyPr rtlCol="0" anchor="ctr"/>
+          <a:lstStyle/>
+          <a:p>
+            <a:pPr algn="ctr"/>
+            <a:endParaRPr lang="hu-HU"/>
+          </a:p>
+        </p:txBody>
+      </p:sp>
+      <p:sp>
+        <p:nvSpPr>
+          <p:cNvPr id="2" name="Téglalap 1">
+            <a:extLst>
+              <a:ext uri="{FF2B5EF4-FFF2-40B4-BE49-F238E27FC236}">
+                <a16:creationId xmlns:a16="http://schemas.microsoft.com/office/drawing/2014/main" id="{E8782545-113C-E27C-CDFC-BC9686C20816}"/>
+              </a:ext>
+            </a:extLst>
+          </p:cNvPr>
+          <p:cNvSpPr/>
+          <p:nvPr/>
+        </p:nvSpPr>
+        <p:spPr>
+          <a:xfrm>
+            <a:off x="5105404" y="3368863"/>
+            <a:ext cx="6506024" cy="717663"/>
+          </a:xfrm>
+          <a:prstGeom prst="rect">
+            <a:avLst/>
+          </a:prstGeom>
+          <a:solidFill>
+            <a:schemeClr val="bg1">
+              <a:lumMod val="75000"/>
+            </a:schemeClr>
+          </a:solidFill>
+        </p:spPr>
+        <p:style>
+          <a:lnRef idx="2">
+            <a:schemeClr val="accent1">
+              <a:shade val="15000"/>
+            </a:schemeClr>
+          </a:lnRef>
+          <a:fillRef idx="1">
+            <a:schemeClr val="accent1"/>
+          </a:fillRef>
+          <a:effectRef idx="0">
+            <a:schemeClr val="accent1"/>
+          </a:effectRef>
+          <a:fontRef idx="minor">
+            <a:schemeClr val="lt1"/>
+          </a:fontRef>
+        </p:style>
+        <p:txBody>
+          <a:bodyPr rtlCol="0" anchor="ctr"/>
+          <a:lstStyle/>
+          <a:p>
+            <a:pPr algn="ctr"/>
+            <a:endParaRPr lang="hu-HU"/>
+          </a:p>
+        </p:txBody>
+      </p:sp>
       <p:cxnSp>
         <p:nvCxnSpPr>
           <p:cNvPr id="12" name="Egyenes összekötő 11">
@@ -6318,8 +6473,8 @@
         </p:blipFill>
         <p:spPr>
           <a:xfrm>
-            <a:off x="6018512" y="1478240"/>
-            <a:ext cx="4055759" cy="1089411"/>
+            <a:off x="5432827" y="1127136"/>
+            <a:ext cx="5897812" cy="1584202"/>
           </a:xfrm>
           <a:prstGeom prst="rect">
             <a:avLst/>
@@ -6340,8 +6495,8 @@
         </p:nvSpPr>
         <p:spPr>
           <a:xfrm>
-            <a:off x="5169839" y="468473"/>
-            <a:ext cx="6734601" cy="707886"/>
+            <a:off x="5763546" y="237640"/>
+            <a:ext cx="5286640" cy="646331"/>
           </a:xfrm>
           <a:prstGeom prst="rect">
             <a:avLst/>
@@ -6355,85 +6510,11 @@
           <a:lstStyle/>
           <a:p>
             <a:r>
-              <a:rPr lang="hu-HU" sz="2000" dirty="0">
+              <a:rPr lang="hu-HU" sz="3600" dirty="0">
                 <a:latin typeface="Arial Black" panose="020B0A04020102020204" pitchFamily="34" charset="0"/>
               </a:rPr>
-              <a:t>Az oldal egy menüpont választóval tárul elénk,</a:t>
+              <a:t>A program így fogad</a:t>
             </a:r>
-          </a:p>
-          <a:p>
-            <a:r>
-              <a:rPr lang="hu-HU" sz="2000" dirty="0">
-                <a:latin typeface="Arial Black" panose="020B0A04020102020204" pitchFamily="34" charset="0"/>
-              </a:rPr>
-              <a:t>amelyet az alábbi ábrán láthatunk</a:t>
-            </a:r>
-          </a:p>
-        </p:txBody>
-      </p:sp>
-      <p:sp>
-        <p:nvSpPr>
-          <p:cNvPr id="16" name="Nyíl: visszakanyarodó 15">
-            <a:extLst>
-              <a:ext uri="{FF2B5EF4-FFF2-40B4-BE49-F238E27FC236}">
-                <a16:creationId xmlns:a16="http://schemas.microsoft.com/office/drawing/2014/main" id="{5928D877-6017-4DBE-8EB7-8838A9DD1BE1}"/>
-              </a:ext>
-            </a:extLst>
-          </p:cNvPr>
-          <p:cNvSpPr/>
-          <p:nvPr/>
-        </p:nvSpPr>
-        <p:spPr>
-          <a:xfrm rot="5400000">
-            <a:off x="9781770" y="1176476"/>
-            <a:ext cx="1368163" cy="783158"/>
-          </a:xfrm>
-          <a:prstGeom prst="uturnArrow">
-            <a:avLst>
-              <a:gd name="adj1" fmla="val 25000"/>
-              <a:gd name="adj2" fmla="val 25000"/>
-              <a:gd name="adj3" fmla="val 25000"/>
-              <a:gd name="adj4" fmla="val 43750"/>
-              <a:gd name="adj5" fmla="val 57143"/>
-            </a:avLst>
-          </a:prstGeom>
-          <a:solidFill>
-            <a:schemeClr val="bg2">
-              <a:lumMod val="75000"/>
-            </a:schemeClr>
-          </a:solidFill>
-          <a:ln>
-            <a:solidFill>
-              <a:schemeClr val="tx1"/>
-            </a:solidFill>
-          </a:ln>
-        </p:spPr>
-        <p:style>
-          <a:lnRef idx="2">
-            <a:schemeClr val="accent1">
-              <a:shade val="50000"/>
-            </a:schemeClr>
-          </a:lnRef>
-          <a:fillRef idx="1">
-            <a:schemeClr val="accent1"/>
-          </a:fillRef>
-          <a:effectRef idx="0">
-            <a:schemeClr val="accent1"/>
-          </a:effectRef>
-          <a:fontRef idx="minor">
-            <a:schemeClr val="lt1"/>
-          </a:fontRef>
-        </p:style>
-        <p:txBody>
-          <a:bodyPr rtlCol="0" anchor="ctr"/>
-          <a:lstStyle/>
-          <a:p>
-            <a:pPr algn="ctr"/>
-            <a:endParaRPr lang="hu-HU">
-              <a:solidFill>
-                <a:schemeClr val="tx1"/>
-              </a:solidFill>
-            </a:endParaRPr>
           </a:p>
         </p:txBody>
       </p:sp>
@@ -6451,8 +6532,8 @@
         </p:nvSpPr>
         <p:spPr>
           <a:xfrm>
-            <a:off x="5169839" y="2625035"/>
-            <a:ext cx="6417141" cy="461665"/>
+            <a:off x="5202302" y="3496863"/>
+            <a:ext cx="6409127" cy="461665"/>
           </a:xfrm>
           <a:prstGeom prst="rect">
             <a:avLst/>
@@ -6469,7 +6550,7 @@
               <a:rPr lang="hu-HU" sz="2400" dirty="0">
                 <a:latin typeface="Impact" panose="020B0806030902050204" pitchFamily="34" charset="0"/>
               </a:rPr>
-              <a:t>Beírja a felhasználó a kívánt menüpont sorszámát</a:t>
+              <a:t>A felhasználó  beírja a kívánt menüpont sorszámát</a:t>
             </a:r>
           </a:p>
         </p:txBody>
@@ -6488,8 +6569,8 @@
         </p:nvSpPr>
         <p:spPr>
           <a:xfrm>
-            <a:off x="5169839" y="3830462"/>
-            <a:ext cx="6721712" cy="461665"/>
+            <a:off x="5303027" y="5218231"/>
+            <a:ext cx="6027612" cy="461665"/>
           </a:xfrm>
           <a:prstGeom prst="rect">
             <a:avLst/>
@@ -6506,7 +6587,7 @@
               <a:rPr lang="hu-HU" sz="2400" dirty="0">
                 <a:latin typeface="Impact" panose="020B0806030902050204" pitchFamily="34" charset="0"/>
               </a:rPr>
-              <a:t>Majd megjelenik a menüpont használható formában</a:t>
+              <a:t>Megjelenik a menüpont használható formában</a:t>
             </a:r>
           </a:p>
         </p:txBody>
@@ -6525,14 +6606,14 @@
         </p:nvSpPr>
         <p:spPr>
           <a:xfrm>
-            <a:off x="8105773" y="3094548"/>
-            <a:ext cx="424922" cy="684601"/>
+            <a:off x="8015205" y="4176639"/>
+            <a:ext cx="603255" cy="826285"/>
           </a:xfrm>
           <a:prstGeom prst="downArrow">
             <a:avLst/>
           </a:prstGeom>
           <a:solidFill>
-            <a:schemeClr val="bg2">
+            <a:schemeClr val="bg1">
               <a:lumMod val="75000"/>
             </a:schemeClr>
           </a:solidFill>
@@ -6779,7 +6860,7 @@
   </p:clrMapOvr>
   <mc:AlternateContent xmlns:mc="http://schemas.openxmlformats.org/markup-compatibility/2006">
     <mc:Choice xmlns:p159="http://schemas.microsoft.com/office/powerpoint/2015/09/main" Requires="p159">
-      <p:transition xmlns:p14="http://schemas.microsoft.com/office/powerpoint/2010/main" spd="slow" p14:dur="2000">
+      <p:transition spd="slow">
         <p159:morph option="byObject"/>
       </p:transition>
     </mc:Choice>
@@ -6789,6 +6870,576 @@
       </p:transition>
     </mc:Fallback>
   </mc:AlternateContent>
+  <p:timing>
+    <p:tnLst>
+      <p:par>
+        <p:cTn id="1" dur="indefinite" restart="never" nodeType="tmRoot">
+          <p:childTnLst>
+            <p:seq concurrent="1" nextAc="seek">
+              <p:cTn id="2" dur="indefinite" nodeType="mainSeq">
+                <p:childTnLst>
+                  <p:par>
+                    <p:cTn id="3" fill="hold">
+                      <p:stCondLst>
+                        <p:cond delay="indefinite"/>
+                        <p:cond evt="onBegin" delay="0">
+                          <p:tn val="2"/>
+                        </p:cond>
+                      </p:stCondLst>
+                      <p:childTnLst>
+                        <p:par>
+                          <p:cTn id="4" fill="hold">
+                            <p:stCondLst>
+                              <p:cond delay="0"/>
+                            </p:stCondLst>
+                            <p:childTnLst>
+                              <p:par>
+                                <p:cTn id="5" presetID="2" presetClass="entr" presetSubtype="1" fill="hold" grpId="0" nodeType="afterEffect">
+                                  <p:stCondLst>
+                                    <p:cond delay="0"/>
+                                  </p:stCondLst>
+                                  <p:childTnLst>
+                                    <p:set>
+                                      <p:cBhvr>
+                                        <p:cTn id="6" dur="1" fill="hold">
+                                          <p:stCondLst>
+                                            <p:cond delay="0"/>
+                                          </p:stCondLst>
+                                        </p:cTn>
+                                        <p:tgtEl>
+                                          <p:spTgt spid="6"/>
+                                        </p:tgtEl>
+                                        <p:attrNameLst>
+                                          <p:attrName>style.visibility</p:attrName>
+                                        </p:attrNameLst>
+                                      </p:cBhvr>
+                                      <p:to>
+                                        <p:strVal val="visible"/>
+                                      </p:to>
+                                    </p:set>
+                                    <p:anim calcmode="lin" valueType="num">
+                                      <p:cBhvr additive="base">
+                                        <p:cTn id="7" dur="250" fill="hold"/>
+                                        <p:tgtEl>
+                                          <p:spTgt spid="6"/>
+                                        </p:tgtEl>
+                                        <p:attrNameLst>
+                                          <p:attrName>ppt_x</p:attrName>
+                                        </p:attrNameLst>
+                                      </p:cBhvr>
+                                      <p:tavLst>
+                                        <p:tav tm="0">
+                                          <p:val>
+                                            <p:strVal val="#ppt_x"/>
+                                          </p:val>
+                                        </p:tav>
+                                        <p:tav tm="100000">
+                                          <p:val>
+                                            <p:strVal val="#ppt_x"/>
+                                          </p:val>
+                                        </p:tav>
+                                      </p:tavLst>
+                                    </p:anim>
+                                    <p:anim calcmode="lin" valueType="num">
+                                      <p:cBhvr additive="base">
+                                        <p:cTn id="8" dur="250" fill="hold"/>
+                                        <p:tgtEl>
+                                          <p:spTgt spid="6"/>
+                                        </p:tgtEl>
+                                        <p:attrNameLst>
+                                          <p:attrName>ppt_y</p:attrName>
+                                        </p:attrNameLst>
+                                      </p:cBhvr>
+                                      <p:tavLst>
+                                        <p:tav tm="0">
+                                          <p:val>
+                                            <p:strVal val="0-#ppt_h/2"/>
+                                          </p:val>
+                                        </p:tav>
+                                        <p:tav tm="100000">
+                                          <p:val>
+                                            <p:strVal val="#ppt_y"/>
+                                          </p:val>
+                                        </p:tav>
+                                      </p:tavLst>
+                                    </p:anim>
+                                  </p:childTnLst>
+                                </p:cTn>
+                              </p:par>
+                              <p:par>
+                                <p:cTn id="9" presetID="2" presetClass="entr" presetSubtype="1" fill="hold" grpId="0" nodeType="withEffect">
+                                  <p:stCondLst>
+                                    <p:cond delay="0"/>
+                                  </p:stCondLst>
+                                  <p:childTnLst>
+                                    <p:set>
+                                      <p:cBhvr>
+                                        <p:cTn id="10" dur="1" fill="hold">
+                                          <p:stCondLst>
+                                            <p:cond delay="0"/>
+                                          </p:stCondLst>
+                                        </p:cTn>
+                                        <p:tgtEl>
+                                          <p:spTgt spid="17"/>
+                                        </p:tgtEl>
+                                        <p:attrNameLst>
+                                          <p:attrName>style.visibility</p:attrName>
+                                        </p:attrNameLst>
+                                      </p:cBhvr>
+                                      <p:to>
+                                        <p:strVal val="visible"/>
+                                      </p:to>
+                                    </p:set>
+                                    <p:anim calcmode="lin" valueType="num">
+                                      <p:cBhvr additive="base">
+                                        <p:cTn id="11" dur="250" fill="hold"/>
+                                        <p:tgtEl>
+                                          <p:spTgt spid="17"/>
+                                        </p:tgtEl>
+                                        <p:attrNameLst>
+                                          <p:attrName>ppt_x</p:attrName>
+                                        </p:attrNameLst>
+                                      </p:cBhvr>
+                                      <p:tavLst>
+                                        <p:tav tm="0">
+                                          <p:val>
+                                            <p:strVal val="#ppt_x"/>
+                                          </p:val>
+                                        </p:tav>
+                                        <p:tav tm="100000">
+                                          <p:val>
+                                            <p:strVal val="#ppt_x"/>
+                                          </p:val>
+                                        </p:tav>
+                                      </p:tavLst>
+                                    </p:anim>
+                                    <p:anim calcmode="lin" valueType="num">
+                                      <p:cBhvr additive="base">
+                                        <p:cTn id="12" dur="250" fill="hold"/>
+                                        <p:tgtEl>
+                                          <p:spTgt spid="17"/>
+                                        </p:tgtEl>
+                                        <p:attrNameLst>
+                                          <p:attrName>ppt_y</p:attrName>
+                                        </p:attrNameLst>
+                                      </p:cBhvr>
+                                      <p:tavLst>
+                                        <p:tav tm="0">
+                                          <p:val>
+                                            <p:strVal val="0-#ppt_h/2"/>
+                                          </p:val>
+                                        </p:tav>
+                                        <p:tav tm="100000">
+                                          <p:val>
+                                            <p:strVal val="#ppt_y"/>
+                                          </p:val>
+                                        </p:tav>
+                                      </p:tavLst>
+                                    </p:anim>
+                                  </p:childTnLst>
+                                </p:cTn>
+                              </p:par>
+                              <p:par>
+                                <p:cTn id="13" presetID="2" presetClass="entr" presetSubtype="1" fill="hold" grpId="0" nodeType="withEffect">
+                                  <p:stCondLst>
+                                    <p:cond delay="0"/>
+                                  </p:stCondLst>
+                                  <p:childTnLst>
+                                    <p:set>
+                                      <p:cBhvr>
+                                        <p:cTn id="14" dur="1" fill="hold">
+                                          <p:stCondLst>
+                                            <p:cond delay="0"/>
+                                          </p:stCondLst>
+                                        </p:cTn>
+                                        <p:tgtEl>
+                                          <p:spTgt spid="2"/>
+                                        </p:tgtEl>
+                                        <p:attrNameLst>
+                                          <p:attrName>style.visibility</p:attrName>
+                                        </p:attrNameLst>
+                                      </p:cBhvr>
+                                      <p:to>
+                                        <p:strVal val="visible"/>
+                                      </p:to>
+                                    </p:set>
+                                    <p:anim calcmode="lin" valueType="num">
+                                      <p:cBhvr additive="base">
+                                        <p:cTn id="15" dur="250" fill="hold"/>
+                                        <p:tgtEl>
+                                          <p:spTgt spid="2"/>
+                                        </p:tgtEl>
+                                        <p:attrNameLst>
+                                          <p:attrName>ppt_x</p:attrName>
+                                        </p:attrNameLst>
+                                      </p:cBhvr>
+                                      <p:tavLst>
+                                        <p:tav tm="0">
+                                          <p:val>
+                                            <p:strVal val="#ppt_x"/>
+                                          </p:val>
+                                        </p:tav>
+                                        <p:tav tm="100000">
+                                          <p:val>
+                                            <p:strVal val="#ppt_x"/>
+                                          </p:val>
+                                        </p:tav>
+                                      </p:tavLst>
+                                    </p:anim>
+                                    <p:anim calcmode="lin" valueType="num">
+                                      <p:cBhvr additive="base">
+                                        <p:cTn id="16" dur="250" fill="hold"/>
+                                        <p:tgtEl>
+                                          <p:spTgt spid="2"/>
+                                        </p:tgtEl>
+                                        <p:attrNameLst>
+                                          <p:attrName>ppt_y</p:attrName>
+                                        </p:attrNameLst>
+                                      </p:cBhvr>
+                                      <p:tavLst>
+                                        <p:tav tm="0">
+                                          <p:val>
+                                            <p:strVal val="0-#ppt_h/2"/>
+                                          </p:val>
+                                        </p:tav>
+                                        <p:tav tm="100000">
+                                          <p:val>
+                                            <p:strVal val="#ppt_y"/>
+                                          </p:val>
+                                        </p:tav>
+                                      </p:tavLst>
+                                    </p:anim>
+                                  </p:childTnLst>
+                                </p:cTn>
+                              </p:par>
+                              <p:par>
+                                <p:cTn id="17" presetID="2" presetClass="entr" presetSubtype="1" fill="hold" nodeType="withEffect">
+                                  <p:stCondLst>
+                                    <p:cond delay="0"/>
+                                  </p:stCondLst>
+                                  <p:childTnLst>
+                                    <p:set>
+                                      <p:cBhvr>
+                                        <p:cTn id="18" dur="1" fill="hold">
+                                          <p:stCondLst>
+                                            <p:cond delay="0"/>
+                                          </p:stCondLst>
+                                        </p:cTn>
+                                        <p:tgtEl>
+                                          <p:spTgt spid="5"/>
+                                        </p:tgtEl>
+                                        <p:attrNameLst>
+                                          <p:attrName>style.visibility</p:attrName>
+                                        </p:attrNameLst>
+                                      </p:cBhvr>
+                                      <p:to>
+                                        <p:strVal val="visible"/>
+                                      </p:to>
+                                    </p:set>
+                                    <p:anim calcmode="lin" valueType="num">
+                                      <p:cBhvr additive="base">
+                                        <p:cTn id="19" dur="250" fill="hold"/>
+                                        <p:tgtEl>
+                                          <p:spTgt spid="5"/>
+                                        </p:tgtEl>
+                                        <p:attrNameLst>
+                                          <p:attrName>ppt_x</p:attrName>
+                                        </p:attrNameLst>
+                                      </p:cBhvr>
+                                      <p:tavLst>
+                                        <p:tav tm="0">
+                                          <p:val>
+                                            <p:strVal val="#ppt_x"/>
+                                          </p:val>
+                                        </p:tav>
+                                        <p:tav tm="100000">
+                                          <p:val>
+                                            <p:strVal val="#ppt_x"/>
+                                          </p:val>
+                                        </p:tav>
+                                      </p:tavLst>
+                                    </p:anim>
+                                    <p:anim calcmode="lin" valueType="num">
+                                      <p:cBhvr additive="base">
+                                        <p:cTn id="20" dur="250" fill="hold"/>
+                                        <p:tgtEl>
+                                          <p:spTgt spid="5"/>
+                                        </p:tgtEl>
+                                        <p:attrNameLst>
+                                          <p:attrName>ppt_y</p:attrName>
+                                        </p:attrNameLst>
+                                      </p:cBhvr>
+                                      <p:tavLst>
+                                        <p:tav tm="0">
+                                          <p:val>
+                                            <p:strVal val="0-#ppt_h/2"/>
+                                          </p:val>
+                                        </p:tav>
+                                        <p:tav tm="100000">
+                                          <p:val>
+                                            <p:strVal val="#ppt_y"/>
+                                          </p:val>
+                                        </p:tav>
+                                      </p:tavLst>
+                                    </p:anim>
+                                  </p:childTnLst>
+                                </p:cTn>
+                              </p:par>
+                              <p:par>
+                                <p:cTn id="21" presetID="2" presetClass="entr" presetSubtype="1" fill="hold" grpId="0" nodeType="withEffect">
+                                  <p:stCondLst>
+                                    <p:cond delay="0"/>
+                                  </p:stCondLst>
+                                  <p:childTnLst>
+                                    <p:set>
+                                      <p:cBhvr>
+                                        <p:cTn id="22" dur="1" fill="hold">
+                                          <p:stCondLst>
+                                            <p:cond delay="0"/>
+                                          </p:stCondLst>
+                                        </p:cTn>
+                                        <p:tgtEl>
+                                          <p:spTgt spid="19"/>
+                                        </p:tgtEl>
+                                        <p:attrNameLst>
+                                          <p:attrName>style.visibility</p:attrName>
+                                        </p:attrNameLst>
+                                      </p:cBhvr>
+                                      <p:to>
+                                        <p:strVal val="visible"/>
+                                      </p:to>
+                                    </p:set>
+                                    <p:anim calcmode="lin" valueType="num">
+                                      <p:cBhvr additive="base">
+                                        <p:cTn id="23" dur="250" fill="hold"/>
+                                        <p:tgtEl>
+                                          <p:spTgt spid="19"/>
+                                        </p:tgtEl>
+                                        <p:attrNameLst>
+                                          <p:attrName>ppt_x</p:attrName>
+                                        </p:attrNameLst>
+                                      </p:cBhvr>
+                                      <p:tavLst>
+                                        <p:tav tm="0">
+                                          <p:val>
+                                            <p:strVal val="#ppt_x"/>
+                                          </p:val>
+                                        </p:tav>
+                                        <p:tav tm="100000">
+                                          <p:val>
+                                            <p:strVal val="#ppt_x"/>
+                                          </p:val>
+                                        </p:tav>
+                                      </p:tavLst>
+                                    </p:anim>
+                                    <p:anim calcmode="lin" valueType="num">
+                                      <p:cBhvr additive="base">
+                                        <p:cTn id="24" dur="250" fill="hold"/>
+                                        <p:tgtEl>
+                                          <p:spTgt spid="19"/>
+                                        </p:tgtEl>
+                                        <p:attrNameLst>
+                                          <p:attrName>ppt_y</p:attrName>
+                                        </p:attrNameLst>
+                                      </p:cBhvr>
+                                      <p:tavLst>
+                                        <p:tav tm="0">
+                                          <p:val>
+                                            <p:strVal val="0-#ppt_h/2"/>
+                                          </p:val>
+                                        </p:tav>
+                                        <p:tav tm="100000">
+                                          <p:val>
+                                            <p:strVal val="#ppt_y"/>
+                                          </p:val>
+                                        </p:tav>
+                                      </p:tavLst>
+                                    </p:anim>
+                                  </p:childTnLst>
+                                </p:cTn>
+                              </p:par>
+                              <p:par>
+                                <p:cTn id="25" presetID="2" presetClass="entr" presetSubtype="1" fill="hold" grpId="0" nodeType="withEffect">
+                                  <p:stCondLst>
+                                    <p:cond delay="0"/>
+                                  </p:stCondLst>
+                                  <p:childTnLst>
+                                    <p:set>
+                                      <p:cBhvr>
+                                        <p:cTn id="26" dur="1" fill="hold">
+                                          <p:stCondLst>
+                                            <p:cond delay="0"/>
+                                          </p:stCondLst>
+                                        </p:cTn>
+                                        <p:tgtEl>
+                                          <p:spTgt spid="18"/>
+                                        </p:tgtEl>
+                                        <p:attrNameLst>
+                                          <p:attrName>style.visibility</p:attrName>
+                                        </p:attrNameLst>
+                                      </p:cBhvr>
+                                      <p:to>
+                                        <p:strVal val="visible"/>
+                                      </p:to>
+                                    </p:set>
+                                    <p:anim calcmode="lin" valueType="num">
+                                      <p:cBhvr additive="base">
+                                        <p:cTn id="27" dur="250" fill="hold"/>
+                                        <p:tgtEl>
+                                          <p:spTgt spid="18"/>
+                                        </p:tgtEl>
+                                        <p:attrNameLst>
+                                          <p:attrName>ppt_x</p:attrName>
+                                        </p:attrNameLst>
+                                      </p:cBhvr>
+                                      <p:tavLst>
+                                        <p:tav tm="0">
+                                          <p:val>
+                                            <p:strVal val="#ppt_x"/>
+                                          </p:val>
+                                        </p:tav>
+                                        <p:tav tm="100000">
+                                          <p:val>
+                                            <p:strVal val="#ppt_x"/>
+                                          </p:val>
+                                        </p:tav>
+                                      </p:tavLst>
+                                    </p:anim>
+                                    <p:anim calcmode="lin" valueType="num">
+                                      <p:cBhvr additive="base">
+                                        <p:cTn id="28" dur="250" fill="hold"/>
+                                        <p:tgtEl>
+                                          <p:spTgt spid="18"/>
+                                        </p:tgtEl>
+                                        <p:attrNameLst>
+                                          <p:attrName>ppt_y</p:attrName>
+                                        </p:attrNameLst>
+                                      </p:cBhvr>
+                                      <p:tavLst>
+                                        <p:tav tm="0">
+                                          <p:val>
+                                            <p:strVal val="0-#ppt_h/2"/>
+                                          </p:val>
+                                        </p:tav>
+                                        <p:tav tm="100000">
+                                          <p:val>
+                                            <p:strVal val="#ppt_y"/>
+                                          </p:val>
+                                        </p:tav>
+                                      </p:tavLst>
+                                    </p:anim>
+                                  </p:childTnLst>
+                                </p:cTn>
+                              </p:par>
+                              <p:par>
+                                <p:cTn id="29" presetID="2" presetClass="entr" presetSubtype="1" fill="hold" grpId="0" nodeType="withEffect">
+                                  <p:stCondLst>
+                                    <p:cond delay="0"/>
+                                  </p:stCondLst>
+                                  <p:childTnLst>
+                                    <p:set>
+                                      <p:cBhvr>
+                                        <p:cTn id="30" dur="1" fill="hold">
+                                          <p:stCondLst>
+                                            <p:cond delay="0"/>
+                                          </p:stCondLst>
+                                        </p:cTn>
+                                        <p:tgtEl>
+                                          <p:spTgt spid="3"/>
+                                        </p:tgtEl>
+                                        <p:attrNameLst>
+                                          <p:attrName>style.visibility</p:attrName>
+                                        </p:attrNameLst>
+                                      </p:cBhvr>
+                                      <p:to>
+                                        <p:strVal val="visible"/>
+                                      </p:to>
+                                    </p:set>
+                                    <p:anim calcmode="lin" valueType="num">
+                                      <p:cBhvr additive="base">
+                                        <p:cTn id="31" dur="250" fill="hold"/>
+                                        <p:tgtEl>
+                                          <p:spTgt spid="3"/>
+                                        </p:tgtEl>
+                                        <p:attrNameLst>
+                                          <p:attrName>ppt_x</p:attrName>
+                                        </p:attrNameLst>
+                                      </p:cBhvr>
+                                      <p:tavLst>
+                                        <p:tav tm="0">
+                                          <p:val>
+                                            <p:strVal val="#ppt_x"/>
+                                          </p:val>
+                                        </p:tav>
+                                        <p:tav tm="100000">
+                                          <p:val>
+                                            <p:strVal val="#ppt_x"/>
+                                          </p:val>
+                                        </p:tav>
+                                      </p:tavLst>
+                                    </p:anim>
+                                    <p:anim calcmode="lin" valueType="num">
+                                      <p:cBhvr additive="base">
+                                        <p:cTn id="32" dur="250" fill="hold"/>
+                                        <p:tgtEl>
+                                          <p:spTgt spid="3"/>
+                                        </p:tgtEl>
+                                        <p:attrNameLst>
+                                          <p:attrName>ppt_y</p:attrName>
+                                        </p:attrNameLst>
+                                      </p:cBhvr>
+                                      <p:tavLst>
+                                        <p:tav tm="0">
+                                          <p:val>
+                                            <p:strVal val="0-#ppt_h/2"/>
+                                          </p:val>
+                                        </p:tav>
+                                        <p:tav tm="100000">
+                                          <p:val>
+                                            <p:strVal val="#ppt_y"/>
+                                          </p:val>
+                                        </p:tav>
+                                      </p:tavLst>
+                                    </p:anim>
+                                  </p:childTnLst>
+                                </p:cTn>
+                              </p:par>
+                            </p:childTnLst>
+                          </p:cTn>
+                        </p:par>
+                      </p:childTnLst>
+                    </p:cTn>
+                  </p:par>
+                </p:childTnLst>
+              </p:cTn>
+              <p:prevCondLst>
+                <p:cond evt="onPrev" delay="0">
+                  <p:tgtEl>
+                    <p:sldTgt/>
+                  </p:tgtEl>
+                </p:cond>
+              </p:prevCondLst>
+              <p:nextCondLst>
+                <p:cond evt="onNext" delay="0">
+                  <p:tgtEl>
+                    <p:sldTgt/>
+                  </p:tgtEl>
+                </p:cond>
+              </p:nextCondLst>
+            </p:seq>
+          </p:childTnLst>
+        </p:cTn>
+      </p:par>
+    </p:tnLst>
+    <p:bldLst>
+      <p:bldP spid="3" grpId="0" animBg="1"/>
+      <p:bldP spid="2" grpId="0" animBg="1"/>
+      <p:bldP spid="6" grpId="0"/>
+      <p:bldP spid="17" grpId="0"/>
+      <p:bldP spid="18" grpId="0"/>
+      <p:bldP spid="19" grpId="0" animBg="1"/>
+    </p:bldLst>
+  </p:timing>
 </p:sld>
 </file>
 
@@ -7033,128 +7684,8 @@
               <a:rPr lang="hu-HU" sz="4400" dirty="0">
                 <a:latin typeface="Impact" panose="020B0806030902050204" pitchFamily="34" charset="0"/>
               </a:rPr>
-              <a:t>Település adatai</a:t>
+              <a:t>Település típusai</a:t>
             </a:r>
-          </a:p>
-        </p:txBody>
-      </p:sp>
-      <p:sp>
-        <p:nvSpPr>
-          <p:cNvPr id="8" name="Téglalap 7">
-            <a:extLst>
-              <a:ext uri="{FF2B5EF4-FFF2-40B4-BE49-F238E27FC236}">
-                <a16:creationId xmlns:a16="http://schemas.microsoft.com/office/drawing/2014/main" id="{8F59965E-6B61-4D1F-9FA7-1793DA9CB3FF}"/>
-              </a:ext>
-            </a:extLst>
-          </p:cNvPr>
-          <p:cNvSpPr/>
-          <p:nvPr/>
-        </p:nvSpPr>
-        <p:spPr>
-          <a:xfrm>
-            <a:off x="-4441508" y="0"/>
-            <a:ext cx="4461933" cy="6858000"/>
-          </a:xfrm>
-          <a:prstGeom prst="rect">
-            <a:avLst/>
-          </a:prstGeom>
-          <a:solidFill>
-            <a:schemeClr val="tx1">
-              <a:lumMod val="75000"/>
-              <a:lumOff val="25000"/>
-            </a:schemeClr>
-          </a:solidFill>
-          <a:ln>
-            <a:noFill/>
-          </a:ln>
-        </p:spPr>
-        <p:style>
-          <a:lnRef idx="2">
-            <a:schemeClr val="accent1">
-              <a:shade val="50000"/>
-            </a:schemeClr>
-          </a:lnRef>
-          <a:fillRef idx="1">
-            <a:schemeClr val="accent1"/>
-          </a:fillRef>
-          <a:effectRef idx="0">
-            <a:schemeClr val="accent1"/>
-          </a:effectRef>
-          <a:fontRef idx="minor">
-            <a:schemeClr val="lt1"/>
-          </a:fontRef>
-        </p:style>
-        <p:txBody>
-          <a:bodyPr rtlCol="0" anchor="ctr"/>
-          <a:lstStyle/>
-          <a:p>
-            <a:pPr algn="ctr"/>
-            <a:endParaRPr lang="hu-HU"/>
-          </a:p>
-        </p:txBody>
-      </p:sp>
-      <p:sp>
-        <p:nvSpPr>
-          <p:cNvPr id="9" name="Cím 1">
-            <a:extLst>
-              <a:ext uri="{FF2B5EF4-FFF2-40B4-BE49-F238E27FC236}">
-                <a16:creationId xmlns:a16="http://schemas.microsoft.com/office/drawing/2014/main" id="{5DF9486F-2BF6-4196-910B-7E38940189B8}"/>
-              </a:ext>
-            </a:extLst>
-          </p:cNvPr>
-          <p:cNvSpPr txBox="1">
-            <a:spLocks/>
-          </p:cNvSpPr>
-          <p:nvPr/>
-        </p:nvSpPr>
-        <p:spPr>
-          <a:xfrm>
-            <a:off x="-4441508" y="221191"/>
-            <a:ext cx="4461933" cy="1325563"/>
-          </a:xfrm>
-          <a:prstGeom prst="rect">
-            <a:avLst/>
-          </a:prstGeom>
-        </p:spPr>
-        <p:txBody>
-          <a:bodyPr vert="horz" lIns="91440" tIns="45720" rIns="91440" bIns="45720" rtlCol="0" anchor="ctr">
-            <a:normAutofit/>
-          </a:bodyPr>
-          <a:lstStyle>
-            <a:lvl1pPr algn="l" defTabSz="914400" rtl="0" eaLnBrk="1" latinLnBrk="0" hangingPunct="1">
-              <a:lnSpc>
-                <a:spcPct val="90000"/>
-              </a:lnSpc>
-              <a:spcBef>
-                <a:spcPct val="0"/>
-              </a:spcBef>
-              <a:buNone/>
-              <a:defRPr sz="4400" kern="1200">
-                <a:solidFill>
-                  <a:schemeClr val="tx1"/>
-                </a:solidFill>
-                <a:latin typeface="+mj-lt"/>
-                <a:ea typeface="+mj-ea"/>
-                <a:cs typeface="+mj-cs"/>
-              </a:defRPr>
-            </a:lvl1pPr>
-          </a:lstStyle>
-          <a:p>
-            <a:r>
-              <a:rPr lang="hu-HU" sz="6000">
-                <a:solidFill>
-                  <a:schemeClr val="bg1"/>
-                </a:solidFill>
-                <a:latin typeface="Impact" panose="020B0806030902050204" pitchFamily="34" charset="0"/>
-              </a:rPr>
-              <a:t>Megye adatai</a:t>
-            </a:r>
-            <a:endParaRPr lang="hu-HU" sz="6000" dirty="0">
-              <a:solidFill>
-                <a:schemeClr val="bg1"/>
-              </a:solidFill>
-              <a:latin typeface="Impact" panose="020B0806030902050204" pitchFamily="34" charset="0"/>
-            </a:endParaRPr>
           </a:p>
         </p:txBody>
       </p:sp>
@@ -7212,6 +7743,207 @@
   <p:transition spd="slow">
     <p:push dir="u"/>
   </p:transition>
+  <p:timing>
+    <p:tnLst>
+      <p:par>
+        <p:cTn id="1" dur="indefinite" restart="never" nodeType="tmRoot">
+          <p:childTnLst>
+            <p:seq concurrent="1" nextAc="seek">
+              <p:cTn id="2" dur="indefinite" nodeType="mainSeq">
+                <p:childTnLst>
+                  <p:par>
+                    <p:cTn id="3" fill="hold">
+                      <p:stCondLst>
+                        <p:cond delay="indefinite"/>
+                        <p:cond evt="onBegin" delay="0">
+                          <p:tn val="2"/>
+                        </p:cond>
+                      </p:stCondLst>
+                      <p:childTnLst>
+                        <p:par>
+                          <p:cTn id="4" fill="hold">
+                            <p:stCondLst>
+                              <p:cond delay="0"/>
+                            </p:stCondLst>
+                            <p:childTnLst>
+                              <p:par>
+                                <p:cTn id="5" presetID="2" presetClass="entr" presetSubtype="8" fill="hold" grpId="0" nodeType="withEffect">
+                                  <p:stCondLst>
+                                    <p:cond delay="0"/>
+                                  </p:stCondLst>
+                                  <p:childTnLst>
+                                    <p:set>
+                                      <p:cBhvr>
+                                        <p:cTn id="6" dur="1" fill="hold">
+                                          <p:stCondLst>
+                                            <p:cond delay="0"/>
+                                          </p:stCondLst>
+                                        </p:cTn>
+                                        <p:tgtEl>
+                                          <p:spTgt spid="52"/>
+                                        </p:tgtEl>
+                                        <p:attrNameLst>
+                                          <p:attrName>style.visibility</p:attrName>
+                                        </p:attrNameLst>
+                                      </p:cBhvr>
+                                      <p:to>
+                                        <p:strVal val="visible"/>
+                                      </p:to>
+                                    </p:set>
+                                    <p:anim calcmode="lin" valueType="num">
+                                      <p:cBhvr additive="base">
+                                        <p:cTn id="7" dur="500" fill="hold"/>
+                                        <p:tgtEl>
+                                          <p:spTgt spid="52"/>
+                                        </p:tgtEl>
+                                        <p:attrNameLst>
+                                          <p:attrName>ppt_x</p:attrName>
+                                        </p:attrNameLst>
+                                      </p:cBhvr>
+                                      <p:tavLst>
+                                        <p:tav tm="0">
+                                          <p:val>
+                                            <p:strVal val="0-#ppt_w/2"/>
+                                          </p:val>
+                                        </p:tav>
+                                        <p:tav tm="100000">
+                                          <p:val>
+                                            <p:strVal val="#ppt_x"/>
+                                          </p:val>
+                                        </p:tav>
+                                      </p:tavLst>
+                                    </p:anim>
+                                    <p:anim calcmode="lin" valueType="num">
+                                      <p:cBhvr additive="base">
+                                        <p:cTn id="8" dur="500" fill="hold"/>
+                                        <p:tgtEl>
+                                          <p:spTgt spid="52"/>
+                                        </p:tgtEl>
+                                        <p:attrNameLst>
+                                          <p:attrName>ppt_y</p:attrName>
+                                        </p:attrNameLst>
+                                      </p:cBhvr>
+                                      <p:tavLst>
+                                        <p:tav tm="0">
+                                          <p:val>
+                                            <p:strVal val="#ppt_y"/>
+                                          </p:val>
+                                        </p:tav>
+                                        <p:tav tm="100000">
+                                          <p:val>
+                                            <p:strVal val="#ppt_y"/>
+                                          </p:val>
+                                        </p:tav>
+                                      </p:tavLst>
+                                    </p:anim>
+                                  </p:childTnLst>
+                                </p:cTn>
+                              </p:par>
+                              <p:par>
+                                <p:cTn id="9" presetID="2" presetClass="entr" presetSubtype="2" fill="hold" grpId="0" nodeType="withEffect">
+                                  <p:stCondLst>
+                                    <p:cond delay="0"/>
+                                  </p:stCondLst>
+                                  <p:childTnLst>
+                                    <p:set>
+                                      <p:cBhvr>
+                                        <p:cTn id="10" dur="1" fill="hold">
+                                          <p:stCondLst>
+                                            <p:cond delay="0"/>
+                                          </p:stCondLst>
+                                        </p:cTn>
+                                        <p:tgtEl>
+                                          <p:spTgt spid="55"/>
+                                        </p:tgtEl>
+                                        <p:attrNameLst>
+                                          <p:attrName>style.visibility</p:attrName>
+                                        </p:attrNameLst>
+                                      </p:cBhvr>
+                                      <p:to>
+                                        <p:strVal val="visible"/>
+                                      </p:to>
+                                    </p:set>
+                                    <p:anim calcmode="lin" valueType="num">
+                                      <p:cBhvr additive="base">
+                                        <p:cTn id="11" dur="500" fill="hold"/>
+                                        <p:tgtEl>
+                                          <p:spTgt spid="55"/>
+                                        </p:tgtEl>
+                                        <p:attrNameLst>
+                                          <p:attrName>ppt_x</p:attrName>
+                                        </p:attrNameLst>
+                                      </p:cBhvr>
+                                      <p:tavLst>
+                                        <p:tav tm="0">
+                                          <p:val>
+                                            <p:strVal val="1+#ppt_w/2"/>
+                                          </p:val>
+                                        </p:tav>
+                                        <p:tav tm="100000">
+                                          <p:val>
+                                            <p:strVal val="#ppt_x"/>
+                                          </p:val>
+                                        </p:tav>
+                                      </p:tavLst>
+                                    </p:anim>
+                                    <p:anim calcmode="lin" valueType="num">
+                                      <p:cBhvr additive="base">
+                                        <p:cTn id="12" dur="500" fill="hold"/>
+                                        <p:tgtEl>
+                                          <p:spTgt spid="55"/>
+                                        </p:tgtEl>
+                                        <p:attrNameLst>
+                                          <p:attrName>ppt_y</p:attrName>
+                                        </p:attrNameLst>
+                                      </p:cBhvr>
+                                      <p:tavLst>
+                                        <p:tav tm="0">
+                                          <p:val>
+                                            <p:strVal val="#ppt_y"/>
+                                          </p:val>
+                                        </p:tav>
+                                        <p:tav tm="100000">
+                                          <p:val>
+                                            <p:strVal val="#ppt_y"/>
+                                          </p:val>
+                                        </p:tav>
+                                      </p:tavLst>
+                                    </p:anim>
+                                  </p:childTnLst>
+                                </p:cTn>
+                              </p:par>
+                            </p:childTnLst>
+                          </p:cTn>
+                        </p:par>
+                      </p:childTnLst>
+                    </p:cTn>
+                  </p:par>
+                </p:childTnLst>
+              </p:cTn>
+              <p:prevCondLst>
+                <p:cond evt="onPrev" delay="0">
+                  <p:tgtEl>
+                    <p:sldTgt/>
+                  </p:tgtEl>
+                </p:cond>
+              </p:prevCondLst>
+              <p:nextCondLst>
+                <p:cond evt="onNext" delay="0">
+                  <p:tgtEl>
+                    <p:sldTgt/>
+                  </p:tgtEl>
+                </p:cond>
+              </p:nextCondLst>
+            </p:seq>
+          </p:childTnLst>
+        </p:cTn>
+      </p:par>
+    </p:tnLst>
+    <p:bldLst>
+      <p:bldP spid="52" grpId="0" animBg="1"/>
+      <p:bldP spid="55" grpId="0" animBg="1"/>
+    </p:bldLst>
+  </p:timing>
 </p:sld>
 </file>
 
@@ -7495,8 +8227,8 @@
         </p:nvSpPr>
         <p:spPr>
           <a:xfrm>
-            <a:off x="4817184" y="376140"/>
-            <a:ext cx="6457361" cy="1323439"/>
+            <a:off x="4820098" y="216331"/>
+            <a:ext cx="6457361" cy="1015663"/>
           </a:xfrm>
           <a:prstGeom prst="rect">
             <a:avLst/>
@@ -7513,7 +8245,23 @@
               <a:rPr lang="hu-HU" sz="2000" dirty="0">
                 <a:latin typeface="Arial Black" panose="020B0A04020102020204" pitchFamily="34" charset="0"/>
               </a:rPr>
-              <a:t>Ebben a menüpontban a program rákérdez a megye kódjára (3 betűből áll), majd a megyében lévő települések számát, az összes lakos, illetve csak a városok lakosait</a:t>
+              <a:t>Ebben a menüpontban a program rákérdez</a:t>
+            </a:r>
+          </a:p>
+          <a:p>
+            <a:r>
+              <a:rPr lang="hu-HU" sz="2000" dirty="0">
+                <a:latin typeface="Arial Black" panose="020B0A04020102020204" pitchFamily="34" charset="0"/>
+              </a:rPr>
+              <a:t>- a megye kódjára (3 betűből áll),</a:t>
+            </a:r>
+          </a:p>
+          <a:p>
+            <a:r>
+              <a:rPr lang="hu-HU" sz="2000" dirty="0">
+                <a:latin typeface="Arial Black" panose="020B0A04020102020204" pitchFamily="34" charset="0"/>
+              </a:rPr>
+              <a:t>- majd kiírja a megyében lévő</a:t>
             </a:r>
           </a:p>
         </p:txBody>
@@ -7531,13 +8279,13 @@
           <p:nvPr>
             <p:extLst>
               <p:ext uri="{D42A27DB-BD31-4B8C-83A1-F6EECF244321}">
-                <p14:modId xmlns:p14="http://schemas.microsoft.com/office/powerpoint/2010/main" val="1252982875"/>
+                <p14:modId xmlns:p14="http://schemas.microsoft.com/office/powerpoint/2010/main" val="596553852"/>
               </p:ext>
             </p:extLst>
           </p:nvPr>
         </p:nvGraphicFramePr>
         <p:xfrm>
-          <a:off x="4724051" y="1334934"/>
+          <a:off x="4820098" y="2286309"/>
           <a:ext cx="7194733" cy="2260601"/>
         </p:xfrm>
         <a:graphic>
@@ -7546,36 +8294,255 @@
           </a:graphicData>
         </a:graphic>
       </p:graphicFrame>
-      <p:pic>
-        <p:nvPicPr>
-          <p:cNvPr id="15" name="Kép 14">
+      <p:grpSp>
+        <p:nvGrpSpPr>
+          <p:cNvPr id="14" name="Csoportba foglalás 13">
             <a:extLst>
               <a:ext uri="{FF2B5EF4-FFF2-40B4-BE49-F238E27FC236}">
-                <a16:creationId xmlns:a16="http://schemas.microsoft.com/office/drawing/2014/main" id="{559B850A-44E6-4E09-9471-4D4697F9C1CC}"/>
+                <a16:creationId xmlns:a16="http://schemas.microsoft.com/office/drawing/2014/main" id="{D8EFCC2A-DFB8-8F91-0CFC-3CA702FA88B9}"/>
               </a:ext>
             </a:extLst>
           </p:cNvPr>
-          <p:cNvPicPr>
-            <a:picLocks noChangeAspect="1"/>
-          </p:cNvPicPr>
+          <p:cNvGrpSpPr/>
           <p:nvPr/>
-        </p:nvPicPr>
-        <p:blipFill>
-          <a:blip r:embed="rId9"/>
-          <a:stretch>
-            <a:fillRect/>
-          </a:stretch>
-        </p:blipFill>
+        </p:nvGrpSpPr>
+        <p:grpSpPr>
+          <a:xfrm>
+            <a:off x="6464684" y="4653426"/>
+            <a:ext cx="3905559" cy="1665948"/>
+            <a:chOff x="6464684" y="4546910"/>
+            <a:chExt cx="3905559" cy="1665948"/>
+          </a:xfrm>
+          <a:solidFill>
+            <a:schemeClr val="bg1">
+              <a:lumMod val="75000"/>
+            </a:schemeClr>
+          </a:solidFill>
+        </p:grpSpPr>
+        <p:sp>
+          <p:nvSpPr>
+            <p:cNvPr id="5" name="Téglalap 4">
+              <a:extLst>
+                <a:ext uri="{FF2B5EF4-FFF2-40B4-BE49-F238E27FC236}">
+                  <a16:creationId xmlns:a16="http://schemas.microsoft.com/office/drawing/2014/main" id="{38F115A7-F70F-CF95-D597-E6F1C4492CE6}"/>
+                </a:ext>
+              </a:extLst>
+            </p:cNvPr>
+            <p:cNvSpPr/>
+            <p:nvPr/>
+          </p:nvSpPr>
+          <p:spPr>
+            <a:xfrm>
+              <a:off x="6464684" y="4546910"/>
+              <a:ext cx="3905559" cy="591163"/>
+            </a:xfrm>
+            <a:prstGeom prst="rect">
+              <a:avLst/>
+            </a:prstGeom>
+            <a:grpFill/>
+          </p:spPr>
+          <p:style>
+            <a:lnRef idx="2">
+              <a:schemeClr val="accent1">
+                <a:shade val="15000"/>
+              </a:schemeClr>
+            </a:lnRef>
+            <a:fillRef idx="1">
+              <a:schemeClr val="accent1"/>
+            </a:fillRef>
+            <a:effectRef idx="0">
+              <a:schemeClr val="accent1"/>
+            </a:effectRef>
+            <a:fontRef idx="minor">
+              <a:schemeClr val="lt1"/>
+            </a:fontRef>
+          </p:style>
+          <p:txBody>
+            <a:bodyPr rtlCol="0" anchor="ctr"/>
+            <a:lstStyle/>
+            <a:p>
+              <a:pPr algn="ctr"/>
+              <a:endParaRPr lang="hu-HU" dirty="0"/>
+            </a:p>
+          </p:txBody>
+        </p:sp>
+        <p:pic>
+          <p:nvPicPr>
+            <p:cNvPr id="15" name="Kép 14">
+              <a:extLst>
+                <a:ext uri="{FF2B5EF4-FFF2-40B4-BE49-F238E27FC236}">
+                  <a16:creationId xmlns:a16="http://schemas.microsoft.com/office/drawing/2014/main" id="{559B850A-44E6-4E09-9471-4D4697F9C1CC}"/>
+                </a:ext>
+              </a:extLst>
+            </p:cNvPr>
+            <p:cNvPicPr>
+              <a:picLocks noChangeAspect="1"/>
+            </p:cNvPicPr>
+            <p:nvPr/>
+          </p:nvPicPr>
+          <p:blipFill>
+            <a:blip r:embed="rId9"/>
+            <a:stretch>
+              <a:fillRect/>
+            </a:stretch>
+          </p:blipFill>
+          <p:spPr>
+            <a:xfrm>
+              <a:off x="6464684" y="5138073"/>
+              <a:ext cx="3905559" cy="1074785"/>
+            </a:xfrm>
+            <a:prstGeom prst="rect">
+              <a:avLst/>
+            </a:prstGeom>
+            <a:grpFill/>
+          </p:spPr>
+        </p:pic>
+        <p:sp>
+          <p:nvSpPr>
+            <p:cNvPr id="3" name="Szövegdoboz 2">
+              <a:extLst>
+                <a:ext uri="{FF2B5EF4-FFF2-40B4-BE49-F238E27FC236}">
+                  <a16:creationId xmlns:a16="http://schemas.microsoft.com/office/drawing/2014/main" id="{0C607E36-1461-05D4-C57B-798C64FA1B22}"/>
+                </a:ext>
+              </a:extLst>
+            </p:cNvPr>
+            <p:cNvSpPr txBox="1"/>
+            <p:nvPr/>
+          </p:nvSpPr>
+          <p:spPr>
+            <a:xfrm>
+              <a:off x="7086938" y="4607480"/>
+              <a:ext cx="2661049" cy="461665"/>
+            </a:xfrm>
+            <a:prstGeom prst="rect">
+              <a:avLst/>
+            </a:prstGeom>
+            <a:grpFill/>
+          </p:spPr>
+          <p:txBody>
+            <a:bodyPr wrap="none" rtlCol="0">
+              <a:spAutoFit/>
+            </a:bodyPr>
+            <a:lstStyle/>
+            <a:p>
+              <a:r>
+                <a:rPr lang="hu-HU" sz="2400" dirty="0">
+                  <a:latin typeface="Arial Black" panose="020B0A04020102020204" pitchFamily="34" charset="0"/>
+                </a:rPr>
+                <a:t>A programban:</a:t>
+              </a:r>
+            </a:p>
+          </p:txBody>
+        </p:sp>
+      </p:grpSp>
+      <p:sp>
+        <p:nvSpPr>
+          <p:cNvPr id="6" name="Szövegdoboz 5">
+            <a:extLst>
+              <a:ext uri="{FF2B5EF4-FFF2-40B4-BE49-F238E27FC236}">
+                <a16:creationId xmlns:a16="http://schemas.microsoft.com/office/drawing/2014/main" id="{5FA58E86-09E3-5659-61B1-5D12BEC08277}"/>
+              </a:ext>
+            </a:extLst>
+          </p:cNvPr>
+          <p:cNvSpPr txBox="1"/>
+          <p:nvPr/>
+        </p:nvSpPr>
         <p:spPr>
           <a:xfrm>
-            <a:off x="6096000" y="3479544"/>
-            <a:ext cx="3905559" cy="1074785"/>
+            <a:off x="4820097" y="1432405"/>
+            <a:ext cx="6673402" cy="1015663"/>
           </a:xfrm>
           <a:prstGeom prst="rect">
             <a:avLst/>
           </a:prstGeom>
+          <a:noFill/>
         </p:spPr>
-      </p:pic>
+        <p:txBody>
+          <a:bodyPr wrap="square" rtlCol="0">
+            <a:spAutoFit/>
+          </a:bodyPr>
+          <a:lstStyle/>
+          <a:p>
+            <a:pPr marL="514350" indent="-514350">
+              <a:buFont typeface="+mj-lt"/>
+              <a:buAutoNum type="romanUcPeriod"/>
+            </a:pPr>
+            <a:r>
+              <a:rPr lang="hu-HU" sz="2000" dirty="0">
+                <a:latin typeface="Arial Black" panose="020B0A04020102020204" pitchFamily="34" charset="0"/>
+              </a:rPr>
+              <a:t>Települések számát</a:t>
+            </a:r>
+          </a:p>
+          <a:p>
+            <a:pPr marL="514350" indent="-514350">
+              <a:buFont typeface="+mj-lt"/>
+              <a:buAutoNum type="romanUcPeriod"/>
+            </a:pPr>
+            <a:r>
+              <a:rPr lang="hu-HU" sz="2000" dirty="0">
+                <a:latin typeface="Arial Black" panose="020B0A04020102020204" pitchFamily="34" charset="0"/>
+              </a:rPr>
+              <a:t>A megye összes lakosának számát</a:t>
+            </a:r>
+          </a:p>
+          <a:p>
+            <a:pPr marL="514350" indent="-514350">
+              <a:buFont typeface="+mj-lt"/>
+              <a:buAutoNum type="romanUcPeriod"/>
+            </a:pPr>
+            <a:r>
+              <a:rPr lang="hu-HU" sz="2000" dirty="0">
+                <a:latin typeface="Arial Black" panose="020B0A04020102020204" pitchFamily="34" charset="0"/>
+              </a:rPr>
+              <a:t>A megye városainak lakosainak számát</a:t>
+            </a:r>
+          </a:p>
+        </p:txBody>
+      </p:sp>
+      <p:cxnSp>
+        <p:nvCxnSpPr>
+          <p:cNvPr id="7" name="Egyenes összekötő 6">
+            <a:extLst>
+              <a:ext uri="{FF2B5EF4-FFF2-40B4-BE49-F238E27FC236}">
+                <a16:creationId xmlns:a16="http://schemas.microsoft.com/office/drawing/2014/main" id="{1C1F5C54-CF81-6EC5-1947-56F16325F927}"/>
+              </a:ext>
+            </a:extLst>
+          </p:cNvPr>
+          <p:cNvCxnSpPr>
+            <a:cxnSpLocks/>
+          </p:cNvCxnSpPr>
+          <p:nvPr/>
+        </p:nvCxnSpPr>
+        <p:spPr>
+          <a:xfrm flipV="1">
+            <a:off x="4461933" y="0"/>
+            <a:ext cx="0" cy="6858000"/>
+          </a:xfrm>
+          <a:prstGeom prst="line">
+            <a:avLst/>
+          </a:prstGeom>
+          <a:ln>
+            <a:solidFill>
+              <a:schemeClr val="bg1"/>
+            </a:solidFill>
+          </a:ln>
+        </p:spPr>
+        <p:style>
+          <a:lnRef idx="1">
+            <a:schemeClr val="accent1"/>
+          </a:lnRef>
+          <a:fillRef idx="0">
+            <a:schemeClr val="accent1"/>
+          </a:fillRef>
+          <a:effectRef idx="0">
+            <a:schemeClr val="accent1"/>
+          </a:effectRef>
+          <a:fontRef idx="minor">
+            <a:schemeClr val="tx1"/>
+          </a:fontRef>
+        </p:style>
+      </p:cxnSp>
     </p:spTree>
     <p:extLst>
       <p:ext uri="{BB962C8B-B14F-4D97-AF65-F5344CB8AC3E}">
@@ -7586,18 +8553,359 @@
   <p:clrMapOvr>
     <a:masterClrMapping/>
   </p:clrMapOvr>
-  <mc:AlternateContent xmlns:mc="http://schemas.openxmlformats.org/markup-compatibility/2006">
-    <mc:Choice xmlns:p159="http://schemas.microsoft.com/office/powerpoint/2015/09/main" Requires="p159">
-      <p:transition xmlns:p14="http://schemas.microsoft.com/office/powerpoint/2010/main" spd="slow" p14:dur="2000">
-        <p159:morph option="byObject"/>
-      </p:transition>
-    </mc:Choice>
-    <mc:Fallback>
-      <p:transition spd="slow">
-        <p:fade/>
-      </p:transition>
-    </mc:Fallback>
-  </mc:AlternateContent>
+  <p:transition spd="slow">
+    <p:push dir="u"/>
+  </p:transition>
+  <p:timing>
+    <p:tnLst>
+      <p:par>
+        <p:cTn id="1" dur="indefinite" restart="never" nodeType="tmRoot">
+          <p:childTnLst>
+            <p:seq concurrent="1" nextAc="seek">
+              <p:cTn id="2" dur="indefinite" nodeType="mainSeq">
+                <p:childTnLst>
+                  <p:par>
+                    <p:cTn id="3" fill="hold">
+                      <p:stCondLst>
+                        <p:cond delay="indefinite"/>
+                        <p:cond evt="onBegin" delay="0">
+                          <p:tn val="2"/>
+                        </p:cond>
+                      </p:stCondLst>
+                      <p:childTnLst>
+                        <p:par>
+                          <p:cTn id="4" fill="hold">
+                            <p:stCondLst>
+                              <p:cond delay="0"/>
+                            </p:stCondLst>
+                            <p:childTnLst>
+                              <p:par>
+                                <p:cTn id="5" presetID="2" presetClass="entr" presetSubtype="1" fill="hold" grpId="0" nodeType="withEffect">
+                                  <p:stCondLst>
+                                    <p:cond delay="0"/>
+                                  </p:stCondLst>
+                                  <p:childTnLst>
+                                    <p:set>
+                                      <p:cBhvr>
+                                        <p:cTn id="6" dur="1" fill="hold">
+                                          <p:stCondLst>
+                                            <p:cond delay="0"/>
+                                          </p:stCondLst>
+                                        </p:cTn>
+                                        <p:tgtEl>
+                                          <p:spTgt spid="17"/>
+                                        </p:tgtEl>
+                                        <p:attrNameLst>
+                                          <p:attrName>style.visibility</p:attrName>
+                                        </p:attrNameLst>
+                                      </p:cBhvr>
+                                      <p:to>
+                                        <p:strVal val="visible"/>
+                                      </p:to>
+                                    </p:set>
+                                    <p:anim calcmode="lin" valueType="num">
+                                      <p:cBhvr additive="base">
+                                        <p:cTn id="7" dur="250" fill="hold"/>
+                                        <p:tgtEl>
+                                          <p:spTgt spid="17"/>
+                                        </p:tgtEl>
+                                        <p:attrNameLst>
+                                          <p:attrName>ppt_x</p:attrName>
+                                        </p:attrNameLst>
+                                      </p:cBhvr>
+                                      <p:tavLst>
+                                        <p:tav tm="0">
+                                          <p:val>
+                                            <p:strVal val="#ppt_x"/>
+                                          </p:val>
+                                        </p:tav>
+                                        <p:tav tm="100000">
+                                          <p:val>
+                                            <p:strVal val="#ppt_x"/>
+                                          </p:val>
+                                        </p:tav>
+                                      </p:tavLst>
+                                    </p:anim>
+                                    <p:anim calcmode="lin" valueType="num">
+                                      <p:cBhvr additive="base">
+                                        <p:cTn id="8" dur="250" fill="hold"/>
+                                        <p:tgtEl>
+                                          <p:spTgt spid="17"/>
+                                        </p:tgtEl>
+                                        <p:attrNameLst>
+                                          <p:attrName>ppt_y</p:attrName>
+                                        </p:attrNameLst>
+                                      </p:cBhvr>
+                                      <p:tavLst>
+                                        <p:tav tm="0">
+                                          <p:val>
+                                            <p:strVal val="0-#ppt_h/2"/>
+                                          </p:val>
+                                        </p:tav>
+                                        <p:tav tm="100000">
+                                          <p:val>
+                                            <p:strVal val="#ppt_y"/>
+                                          </p:val>
+                                        </p:tav>
+                                      </p:tavLst>
+                                    </p:anim>
+                                  </p:childTnLst>
+                                </p:cTn>
+                              </p:par>
+                              <p:par>
+                                <p:cTn id="9" presetID="2" presetClass="entr" presetSubtype="1" fill="hold" grpId="0" nodeType="withEffect">
+                                  <p:stCondLst>
+                                    <p:cond delay="0"/>
+                                  </p:stCondLst>
+                                  <p:childTnLst>
+                                    <p:set>
+                                      <p:cBhvr>
+                                        <p:cTn id="10" dur="1" fill="hold">
+                                          <p:stCondLst>
+                                            <p:cond delay="0"/>
+                                          </p:stCondLst>
+                                        </p:cTn>
+                                        <p:tgtEl>
+                                          <p:spTgt spid="6"/>
+                                        </p:tgtEl>
+                                        <p:attrNameLst>
+                                          <p:attrName>style.visibility</p:attrName>
+                                        </p:attrNameLst>
+                                      </p:cBhvr>
+                                      <p:to>
+                                        <p:strVal val="visible"/>
+                                      </p:to>
+                                    </p:set>
+                                    <p:anim calcmode="lin" valueType="num">
+                                      <p:cBhvr additive="base">
+                                        <p:cTn id="11" dur="250" fill="hold"/>
+                                        <p:tgtEl>
+                                          <p:spTgt spid="6"/>
+                                        </p:tgtEl>
+                                        <p:attrNameLst>
+                                          <p:attrName>ppt_x</p:attrName>
+                                        </p:attrNameLst>
+                                      </p:cBhvr>
+                                      <p:tavLst>
+                                        <p:tav tm="0">
+                                          <p:val>
+                                            <p:strVal val="#ppt_x"/>
+                                          </p:val>
+                                        </p:tav>
+                                        <p:tav tm="100000">
+                                          <p:val>
+                                            <p:strVal val="#ppt_x"/>
+                                          </p:val>
+                                        </p:tav>
+                                      </p:tavLst>
+                                    </p:anim>
+                                    <p:anim calcmode="lin" valueType="num">
+                                      <p:cBhvr additive="base">
+                                        <p:cTn id="12" dur="250" fill="hold"/>
+                                        <p:tgtEl>
+                                          <p:spTgt spid="6"/>
+                                        </p:tgtEl>
+                                        <p:attrNameLst>
+                                          <p:attrName>ppt_y</p:attrName>
+                                        </p:attrNameLst>
+                                      </p:cBhvr>
+                                      <p:tavLst>
+                                        <p:tav tm="0">
+                                          <p:val>
+                                            <p:strVal val="0-#ppt_h/2"/>
+                                          </p:val>
+                                        </p:tav>
+                                        <p:tav tm="100000">
+                                          <p:val>
+                                            <p:strVal val="#ppt_y"/>
+                                          </p:val>
+                                        </p:tav>
+                                      </p:tavLst>
+                                    </p:anim>
+                                  </p:childTnLst>
+                                </p:cTn>
+                              </p:par>
+                              <p:par>
+                                <p:cTn id="13" presetID="2" presetClass="entr" presetSubtype="1" fill="hold" grpId="0" nodeType="withEffect">
+                                  <p:stCondLst>
+                                    <p:cond delay="0"/>
+                                  </p:stCondLst>
+                                  <p:childTnLst>
+                                    <p:set>
+                                      <p:cBhvr>
+                                        <p:cTn id="14" dur="1" fill="hold">
+                                          <p:stCondLst>
+                                            <p:cond delay="0"/>
+                                          </p:stCondLst>
+                                        </p:cTn>
+                                        <p:tgtEl>
+                                          <p:spTgt spid="13"/>
+                                        </p:tgtEl>
+                                        <p:attrNameLst>
+                                          <p:attrName>style.visibility</p:attrName>
+                                        </p:attrNameLst>
+                                      </p:cBhvr>
+                                      <p:to>
+                                        <p:strVal val="visible"/>
+                                      </p:to>
+                                    </p:set>
+                                    <p:anim calcmode="lin" valueType="num">
+                                      <p:cBhvr additive="base">
+                                        <p:cTn id="15" dur="250" fill="hold"/>
+                                        <p:tgtEl>
+                                          <p:spTgt spid="13"/>
+                                        </p:tgtEl>
+                                        <p:attrNameLst>
+                                          <p:attrName>ppt_x</p:attrName>
+                                        </p:attrNameLst>
+                                      </p:cBhvr>
+                                      <p:tavLst>
+                                        <p:tav tm="0">
+                                          <p:val>
+                                            <p:strVal val="#ppt_x"/>
+                                          </p:val>
+                                        </p:tav>
+                                        <p:tav tm="100000">
+                                          <p:val>
+                                            <p:strVal val="#ppt_x"/>
+                                          </p:val>
+                                        </p:tav>
+                                      </p:tavLst>
+                                    </p:anim>
+                                    <p:anim calcmode="lin" valueType="num">
+                                      <p:cBhvr additive="base">
+                                        <p:cTn id="16" dur="250" fill="hold"/>
+                                        <p:tgtEl>
+                                          <p:spTgt spid="13"/>
+                                        </p:tgtEl>
+                                        <p:attrNameLst>
+                                          <p:attrName>ppt_y</p:attrName>
+                                        </p:attrNameLst>
+                                      </p:cBhvr>
+                                      <p:tavLst>
+                                        <p:tav tm="0">
+                                          <p:val>
+                                            <p:strVal val="0-#ppt_h/2"/>
+                                          </p:val>
+                                        </p:tav>
+                                        <p:tav tm="100000">
+                                          <p:val>
+                                            <p:strVal val="#ppt_y"/>
+                                          </p:val>
+                                        </p:tav>
+                                      </p:tavLst>
+                                    </p:anim>
+                                  </p:childTnLst>
+                                </p:cTn>
+                              </p:par>
+                              <p:par>
+                                <p:cTn id="17" presetID="2" presetClass="entr" presetSubtype="1" fill="hold" nodeType="withEffect">
+                                  <p:stCondLst>
+                                    <p:cond delay="0"/>
+                                  </p:stCondLst>
+                                  <p:childTnLst>
+                                    <p:set>
+                                      <p:cBhvr>
+                                        <p:cTn id="18" dur="1" fill="hold">
+                                          <p:stCondLst>
+                                            <p:cond delay="0"/>
+                                          </p:stCondLst>
+                                        </p:cTn>
+                                        <p:tgtEl>
+                                          <p:spTgt spid="14"/>
+                                        </p:tgtEl>
+                                        <p:attrNameLst>
+                                          <p:attrName>style.visibility</p:attrName>
+                                        </p:attrNameLst>
+                                      </p:cBhvr>
+                                      <p:to>
+                                        <p:strVal val="visible"/>
+                                      </p:to>
+                                    </p:set>
+                                    <p:anim calcmode="lin" valueType="num">
+                                      <p:cBhvr additive="base">
+                                        <p:cTn id="19" dur="250" fill="hold"/>
+                                        <p:tgtEl>
+                                          <p:spTgt spid="14"/>
+                                        </p:tgtEl>
+                                        <p:attrNameLst>
+                                          <p:attrName>ppt_x</p:attrName>
+                                        </p:attrNameLst>
+                                      </p:cBhvr>
+                                      <p:tavLst>
+                                        <p:tav tm="0">
+                                          <p:val>
+                                            <p:strVal val="#ppt_x"/>
+                                          </p:val>
+                                        </p:tav>
+                                        <p:tav tm="100000">
+                                          <p:val>
+                                            <p:strVal val="#ppt_x"/>
+                                          </p:val>
+                                        </p:tav>
+                                      </p:tavLst>
+                                    </p:anim>
+                                    <p:anim calcmode="lin" valueType="num">
+                                      <p:cBhvr additive="base">
+                                        <p:cTn id="20" dur="250" fill="hold"/>
+                                        <p:tgtEl>
+                                          <p:spTgt spid="14"/>
+                                        </p:tgtEl>
+                                        <p:attrNameLst>
+                                          <p:attrName>ppt_y</p:attrName>
+                                        </p:attrNameLst>
+                                      </p:cBhvr>
+                                      <p:tavLst>
+                                        <p:tav tm="0">
+                                          <p:val>
+                                            <p:strVal val="0-#ppt_h/2"/>
+                                          </p:val>
+                                        </p:tav>
+                                        <p:tav tm="100000">
+                                          <p:val>
+                                            <p:strVal val="#ppt_y"/>
+                                          </p:val>
+                                        </p:tav>
+                                      </p:tavLst>
+                                    </p:anim>
+                                  </p:childTnLst>
+                                </p:cTn>
+                              </p:par>
+                            </p:childTnLst>
+                          </p:cTn>
+                        </p:par>
+                      </p:childTnLst>
+                    </p:cTn>
+                  </p:par>
+                </p:childTnLst>
+              </p:cTn>
+              <p:prevCondLst>
+                <p:cond evt="onPrev" delay="0">
+                  <p:tgtEl>
+                    <p:sldTgt/>
+                  </p:tgtEl>
+                </p:cond>
+              </p:prevCondLst>
+              <p:nextCondLst>
+                <p:cond evt="onNext" delay="0">
+                  <p:tgtEl>
+                    <p:sldTgt/>
+                  </p:tgtEl>
+                </p:cond>
+              </p:nextCondLst>
+            </p:seq>
+          </p:childTnLst>
+        </p:cTn>
+      </p:par>
+    </p:tnLst>
+    <p:bldLst>
+      <p:bldP spid="17" grpId="0"/>
+      <p:bldGraphic spid="13" grpId="0">
+        <p:bldAsOne/>
+      </p:bldGraphic>
+      <p:bldP spid="6" grpId="0"/>
+    </p:bldLst>
+  </p:timing>
 </p:sld>
 </file>
 
@@ -7926,116 +9234,6 @@
         <p:spPr>
           <a:xfrm>
             <a:off x="4817184" y="376140"/>
-            <a:ext cx="6457361" cy="400110"/>
-          </a:xfrm>
-          <a:prstGeom prst="rect">
-            <a:avLst/>
-          </a:prstGeom>
-          <a:noFill/>
-        </p:spPr>
-        <p:txBody>
-          <a:bodyPr wrap="square" rtlCol="0">
-            <a:spAutoFit/>
-          </a:bodyPr>
-          <a:lstStyle/>
-          <a:p>
-            <a:r>
-              <a:rPr lang="hu-HU" sz="2000" dirty="0">
-                <a:latin typeface="Arial Black" panose="020B0A04020102020204" pitchFamily="34" charset="0"/>
-              </a:rPr>
-              <a:t>Egy listából számok kiválasztásával:</a:t>
-            </a:r>
-          </a:p>
-        </p:txBody>
-      </p:sp>
-      <p:pic>
-        <p:nvPicPr>
-          <p:cNvPr id="6" name="Kép 5">
-            <a:extLst>
-              <a:ext uri="{FF2B5EF4-FFF2-40B4-BE49-F238E27FC236}">
-                <a16:creationId xmlns:a16="http://schemas.microsoft.com/office/drawing/2014/main" id="{2845BB08-CA8E-4007-9A54-8C1486EB7164}"/>
-              </a:ext>
-            </a:extLst>
-          </p:cNvPr>
-          <p:cNvPicPr>
-            <a:picLocks noChangeAspect="1"/>
-          </p:cNvPicPr>
-          <p:nvPr/>
-        </p:nvPicPr>
-        <p:blipFill>
-          <a:blip r:embed="rId4">
-            <a:extLst>
-              <a:ext uri="{28A0092B-C50C-407E-A947-70E740481C1C}">
-                <a14:useLocalDpi xmlns:a14="http://schemas.microsoft.com/office/drawing/2010/main" val="0"/>
-              </a:ext>
-            </a:extLst>
-          </a:blip>
-          <a:stretch>
-            <a:fillRect/>
-          </a:stretch>
-        </p:blipFill>
-        <p:spPr>
-          <a:xfrm>
-            <a:off x="5401383" y="943470"/>
-            <a:ext cx="4526054" cy="2118254"/>
-          </a:xfrm>
-          <a:prstGeom prst="rect">
-            <a:avLst/>
-          </a:prstGeom>
-        </p:spPr>
-      </p:pic>
-      <p:sp>
-        <p:nvSpPr>
-          <p:cNvPr id="13" name="Szövegdoboz 12">
-            <a:extLst>
-              <a:ext uri="{FF2B5EF4-FFF2-40B4-BE49-F238E27FC236}">
-                <a16:creationId xmlns:a16="http://schemas.microsoft.com/office/drawing/2014/main" id="{22AF7B0F-B28D-451D-9782-D632EDD435E8}"/>
-              </a:ext>
-            </a:extLst>
-          </p:cNvPr>
-          <p:cNvSpPr txBox="1"/>
-          <p:nvPr/>
-        </p:nvSpPr>
-        <p:spPr>
-          <a:xfrm>
-            <a:off x="4749451" y="3228945"/>
-            <a:ext cx="6457361" cy="1015663"/>
-          </a:xfrm>
-          <a:prstGeom prst="rect">
-            <a:avLst/>
-          </a:prstGeom>
-          <a:noFill/>
-        </p:spPr>
-        <p:txBody>
-          <a:bodyPr wrap="square" rtlCol="0">
-            <a:spAutoFit/>
-          </a:bodyPr>
-          <a:lstStyle/>
-          <a:p>
-            <a:r>
-              <a:rPr lang="hu-HU" sz="2000" dirty="0">
-                <a:latin typeface="Arial Black" panose="020B0A04020102020204" pitchFamily="34" charset="0"/>
-              </a:rPr>
-              <a:t>Megtudhatjuk azoknak a településeknek a nevét, és lakosságát, amely településtípusba tartoznak</a:t>
-            </a:r>
-          </a:p>
-        </p:txBody>
-      </p:sp>
-      <p:sp>
-        <p:nvSpPr>
-          <p:cNvPr id="14" name="Szövegdoboz 13">
-            <a:extLst>
-              <a:ext uri="{FF2B5EF4-FFF2-40B4-BE49-F238E27FC236}">
-                <a16:creationId xmlns:a16="http://schemas.microsoft.com/office/drawing/2014/main" id="{46ACAD30-E5CE-40BA-93F7-099567E64D87}"/>
-              </a:ext>
-            </a:extLst>
-          </p:cNvPr>
-          <p:cNvSpPr txBox="1"/>
-          <p:nvPr/>
-        </p:nvSpPr>
-        <p:spPr>
-          <a:xfrm>
-            <a:off x="4749450" y="4558673"/>
             <a:ext cx="6457361" cy="707886"/>
           </a:xfrm>
           <a:prstGeom prst="rect">
@@ -8053,8 +9251,325 @@
               <a:rPr lang="hu-HU" sz="2000" dirty="0">
                 <a:latin typeface="Arial Black" panose="020B0A04020102020204" pitchFamily="34" charset="0"/>
               </a:rPr>
-              <a:t>Ezt egy kényelmes lapozási lehetőséggel olvashatóbbá teszi</a:t>
+              <a:t>Egy listából számok kiválasztásával megtudhatjuk:</a:t>
             </a:r>
+          </a:p>
+        </p:txBody>
+      </p:sp>
+      <p:grpSp>
+        <p:nvGrpSpPr>
+          <p:cNvPr id="18" name="Csoportba foglalás 17">
+            <a:extLst>
+              <a:ext uri="{FF2B5EF4-FFF2-40B4-BE49-F238E27FC236}">
+                <a16:creationId xmlns:a16="http://schemas.microsoft.com/office/drawing/2014/main" id="{5B4167CF-4844-75EB-9DB4-14989F60C2F1}"/>
+              </a:ext>
+            </a:extLst>
+          </p:cNvPr>
+          <p:cNvGrpSpPr/>
+          <p:nvPr/>
+        </p:nvGrpSpPr>
+        <p:grpSpPr>
+          <a:xfrm>
+            <a:off x="4698999" y="2650195"/>
+            <a:ext cx="7238996" cy="931848"/>
+            <a:chOff x="4699000" y="2738452"/>
+            <a:chExt cx="7238996" cy="931848"/>
+          </a:xfrm>
+        </p:grpSpPr>
+        <p:sp>
+          <p:nvSpPr>
+            <p:cNvPr id="17" name="Téglalap 16">
+              <a:extLst>
+                <a:ext uri="{FF2B5EF4-FFF2-40B4-BE49-F238E27FC236}">
+                  <a16:creationId xmlns:a16="http://schemas.microsoft.com/office/drawing/2014/main" id="{2FB91248-3866-72A2-970B-E2397F98CA6F}"/>
+                </a:ext>
+              </a:extLst>
+            </p:cNvPr>
+            <p:cNvSpPr/>
+            <p:nvPr/>
+          </p:nvSpPr>
+          <p:spPr>
+            <a:xfrm>
+              <a:off x="4699000" y="2738452"/>
+              <a:ext cx="7238995" cy="931848"/>
+            </a:xfrm>
+            <a:prstGeom prst="rect">
+              <a:avLst/>
+            </a:prstGeom>
+            <a:solidFill>
+              <a:schemeClr val="bg1">
+                <a:lumMod val="75000"/>
+              </a:schemeClr>
+            </a:solidFill>
+            <a:ln w="38100">
+              <a:solidFill>
+                <a:srgbClr val="C00000"/>
+              </a:solidFill>
+            </a:ln>
+          </p:spPr>
+          <p:style>
+            <a:lnRef idx="2">
+              <a:schemeClr val="accent1">
+                <a:shade val="15000"/>
+              </a:schemeClr>
+            </a:lnRef>
+            <a:fillRef idx="1">
+              <a:schemeClr val="accent1"/>
+            </a:fillRef>
+            <a:effectRef idx="0">
+              <a:schemeClr val="accent1"/>
+            </a:effectRef>
+            <a:fontRef idx="minor">
+              <a:schemeClr val="lt1"/>
+            </a:fontRef>
+          </p:style>
+          <p:txBody>
+            <a:bodyPr rtlCol="0" anchor="ctr"/>
+            <a:lstStyle/>
+            <a:p>
+              <a:pPr algn="ctr"/>
+              <a:endParaRPr lang="hu-HU"/>
+            </a:p>
+          </p:txBody>
+        </p:sp>
+        <p:sp>
+          <p:nvSpPr>
+            <p:cNvPr id="14" name="Szövegdoboz 13">
+              <a:extLst>
+                <a:ext uri="{FF2B5EF4-FFF2-40B4-BE49-F238E27FC236}">
+                  <a16:creationId xmlns:a16="http://schemas.microsoft.com/office/drawing/2014/main" id="{46ACAD30-E5CE-40BA-93F7-099567E64D87}"/>
+                </a:ext>
+              </a:extLst>
+            </p:cNvPr>
+            <p:cNvSpPr txBox="1"/>
+            <p:nvPr/>
+          </p:nvSpPr>
+          <p:spPr>
+            <a:xfrm>
+              <a:off x="4817184" y="2838067"/>
+              <a:ext cx="7120812" cy="830997"/>
+            </a:xfrm>
+            <a:prstGeom prst="rect">
+              <a:avLst/>
+            </a:prstGeom>
+            <a:noFill/>
+          </p:spPr>
+          <p:txBody>
+            <a:bodyPr wrap="square" rtlCol="0">
+              <a:spAutoFit/>
+            </a:bodyPr>
+            <a:lstStyle/>
+            <a:p>
+              <a:r>
+                <a:rPr lang="hu-HU" sz="2400" dirty="0">
+                  <a:latin typeface="Arial Black" panose="020B0A04020102020204" pitchFamily="34" charset="0"/>
+                </a:rPr>
+                <a:t>Ezt egy kényelmes lapozási lehetőséggel olvashatóbbá teszi!</a:t>
+              </a:r>
+            </a:p>
+          </p:txBody>
+        </p:sp>
+      </p:grpSp>
+      <p:grpSp>
+        <p:nvGrpSpPr>
+          <p:cNvPr id="20" name="Csoportba foglalás 19">
+            <a:extLst>
+              <a:ext uri="{FF2B5EF4-FFF2-40B4-BE49-F238E27FC236}">
+                <a16:creationId xmlns:a16="http://schemas.microsoft.com/office/drawing/2014/main" id="{FA4366A5-E59D-457D-463B-41C0F09ABE7E}"/>
+              </a:ext>
+            </a:extLst>
+          </p:cNvPr>
+          <p:cNvGrpSpPr/>
+          <p:nvPr/>
+        </p:nvGrpSpPr>
+        <p:grpSpPr>
+          <a:xfrm>
+            <a:off x="6136630" y="4119548"/>
+            <a:ext cx="3905559" cy="2419016"/>
+            <a:chOff x="6136630" y="4119548"/>
+            <a:chExt cx="3905559" cy="2419016"/>
+          </a:xfrm>
+        </p:grpSpPr>
+        <p:pic>
+          <p:nvPicPr>
+            <p:cNvPr id="16" name="Kép 15">
+              <a:extLst>
+                <a:ext uri="{FF2B5EF4-FFF2-40B4-BE49-F238E27FC236}">
+                  <a16:creationId xmlns:a16="http://schemas.microsoft.com/office/drawing/2014/main" id="{843F08E9-0B8A-4D3D-9079-2F26E93419E9}"/>
+                </a:ext>
+              </a:extLst>
+            </p:cNvPr>
+            <p:cNvPicPr>
+              <a:picLocks noChangeAspect="1"/>
+            </p:cNvPicPr>
+            <p:nvPr/>
+          </p:nvPicPr>
+          <p:blipFill>
+            <a:blip r:embed="rId4">
+              <a:extLst>
+                <a:ext uri="{28A0092B-C50C-407E-A947-70E740481C1C}">
+                  <a14:useLocalDpi xmlns:a14="http://schemas.microsoft.com/office/drawing/2010/main" val="0"/>
+                </a:ext>
+              </a:extLst>
+            </a:blip>
+            <a:stretch>
+              <a:fillRect/>
+            </a:stretch>
+          </p:blipFill>
+          <p:spPr>
+            <a:xfrm>
+              <a:off x="6136630" y="4710711"/>
+              <a:ext cx="3905556" cy="1827853"/>
+            </a:xfrm>
+            <a:prstGeom prst="rect">
+              <a:avLst/>
+            </a:prstGeom>
+          </p:spPr>
+        </p:pic>
+        <p:sp>
+          <p:nvSpPr>
+            <p:cNvPr id="5" name="Téglalap 4">
+              <a:extLst>
+                <a:ext uri="{FF2B5EF4-FFF2-40B4-BE49-F238E27FC236}">
+                  <a16:creationId xmlns:a16="http://schemas.microsoft.com/office/drawing/2014/main" id="{546D0B23-CE06-7D40-EE6A-100D539DDEF0}"/>
+                </a:ext>
+              </a:extLst>
+            </p:cNvPr>
+            <p:cNvSpPr/>
+            <p:nvPr/>
+          </p:nvSpPr>
+          <p:spPr>
+            <a:xfrm>
+              <a:off x="6136630" y="4119548"/>
+              <a:ext cx="3905559" cy="591163"/>
+            </a:xfrm>
+            <a:prstGeom prst="rect">
+              <a:avLst/>
+            </a:prstGeom>
+            <a:solidFill>
+              <a:schemeClr val="bg1">
+                <a:lumMod val="75000"/>
+              </a:schemeClr>
+            </a:solidFill>
+          </p:spPr>
+          <p:style>
+            <a:lnRef idx="2">
+              <a:schemeClr val="accent1">
+                <a:shade val="15000"/>
+              </a:schemeClr>
+            </a:lnRef>
+            <a:fillRef idx="1">
+              <a:schemeClr val="accent1"/>
+            </a:fillRef>
+            <a:effectRef idx="0">
+              <a:schemeClr val="accent1"/>
+            </a:effectRef>
+            <a:fontRef idx="minor">
+              <a:schemeClr val="lt1"/>
+            </a:fontRef>
+          </p:style>
+          <p:txBody>
+            <a:bodyPr rtlCol="0" anchor="ctr"/>
+            <a:lstStyle/>
+            <a:p>
+              <a:pPr algn="ctr"/>
+              <a:endParaRPr lang="hu-HU" dirty="0"/>
+            </a:p>
+          </p:txBody>
+        </p:sp>
+        <p:sp>
+          <p:nvSpPr>
+            <p:cNvPr id="7" name="Szövegdoboz 6">
+              <a:extLst>
+                <a:ext uri="{FF2B5EF4-FFF2-40B4-BE49-F238E27FC236}">
+                  <a16:creationId xmlns:a16="http://schemas.microsoft.com/office/drawing/2014/main" id="{87987330-7FA7-9D37-2AD7-53F4E870DD82}"/>
+                </a:ext>
+              </a:extLst>
+            </p:cNvPr>
+            <p:cNvSpPr txBox="1"/>
+            <p:nvPr/>
+          </p:nvSpPr>
+          <p:spPr>
+            <a:xfrm>
+              <a:off x="6692408" y="4179075"/>
+              <a:ext cx="2794000" cy="461665"/>
+            </a:xfrm>
+            <a:prstGeom prst="rect">
+              <a:avLst/>
+            </a:prstGeom>
+            <a:noFill/>
+          </p:spPr>
+          <p:txBody>
+            <a:bodyPr wrap="square" rtlCol="0">
+              <a:spAutoFit/>
+            </a:bodyPr>
+            <a:lstStyle/>
+            <a:p>
+              <a:r>
+                <a:rPr lang="hu-HU" sz="2400" dirty="0">
+                  <a:latin typeface="Arial Black" panose="020B0A04020102020204" pitchFamily="34" charset="0"/>
+                </a:rPr>
+                <a:t>A programban:</a:t>
+              </a:r>
+            </a:p>
+          </p:txBody>
+        </p:sp>
+      </p:grpSp>
+      <p:sp>
+        <p:nvSpPr>
+          <p:cNvPr id="15" name="Szövegdoboz 14">
+            <a:extLst>
+              <a:ext uri="{FF2B5EF4-FFF2-40B4-BE49-F238E27FC236}">
+                <a16:creationId xmlns:a16="http://schemas.microsoft.com/office/drawing/2014/main" id="{586A0087-FBE2-1D0B-D0E8-E0BC950C4D2A}"/>
+              </a:ext>
+            </a:extLst>
+          </p:cNvPr>
+          <p:cNvSpPr txBox="1"/>
+          <p:nvPr/>
+        </p:nvSpPr>
+        <p:spPr>
+          <a:xfrm>
+            <a:off x="4817184" y="1256785"/>
+            <a:ext cx="7120815" cy="1323439"/>
+          </a:xfrm>
+          <a:prstGeom prst="rect">
+            <a:avLst/>
+          </a:prstGeom>
+          <a:noFill/>
+        </p:spPr>
+        <p:txBody>
+          <a:bodyPr wrap="square" rtlCol="0">
+            <a:spAutoFit/>
+          </a:bodyPr>
+          <a:lstStyle/>
+          <a:p>
+            <a:pPr marL="514350" indent="-514350">
+              <a:buFont typeface="+mj-lt"/>
+              <a:buAutoNum type="romanUcPeriod"/>
+            </a:pPr>
+            <a:r>
+              <a:rPr lang="hu-HU" sz="2000" dirty="0">
+                <a:latin typeface="Arial Black" panose="020B0A04020102020204" pitchFamily="34" charset="0"/>
+              </a:rPr>
+              <a:t>A megegyező típusú települések nevét és lakosságának számát</a:t>
+            </a:r>
+          </a:p>
+          <a:p>
+            <a:pPr marL="514350" indent="-514350">
+              <a:buFont typeface="+mj-lt"/>
+              <a:buAutoNum type="romanUcPeriod"/>
+            </a:pPr>
+            <a:r>
+              <a:rPr lang="hu-HU" sz="2000" dirty="0">
+                <a:latin typeface="Arial Black" panose="020B0A04020102020204" pitchFamily="34" charset="0"/>
+              </a:rPr>
+              <a:t>Mely településtípusba tartoznak</a:t>
+            </a:r>
+          </a:p>
+          <a:p>
+            <a:endParaRPr lang="hu-HU" sz="2000" dirty="0">
+              <a:latin typeface="Arial Black" panose="020B0A04020102020204" pitchFamily="34" charset="0"/>
+            </a:endParaRPr>
           </a:p>
         </p:txBody>
       </p:sp>
@@ -8071,10 +9586,1279 @@
   <p:transition spd="slow">
     <p:push dir="u"/>
   </p:transition>
+  <p:timing>
+    <p:tnLst>
+      <p:par>
+        <p:cTn id="1" dur="indefinite" restart="never" nodeType="tmRoot">
+          <p:childTnLst>
+            <p:seq concurrent="1" nextAc="seek">
+              <p:cTn id="2" dur="indefinite" nodeType="mainSeq">
+                <p:childTnLst>
+                  <p:par>
+                    <p:cTn id="3" fill="hold">
+                      <p:stCondLst>
+                        <p:cond delay="indefinite"/>
+                        <p:cond evt="onBegin" delay="0">
+                          <p:tn val="2"/>
+                        </p:cond>
+                      </p:stCondLst>
+                      <p:childTnLst>
+                        <p:par>
+                          <p:cTn id="4" fill="hold">
+                            <p:stCondLst>
+                              <p:cond delay="0"/>
+                            </p:stCondLst>
+                            <p:childTnLst>
+                              <p:par>
+                                <p:cTn id="5" presetID="2" presetClass="entr" presetSubtype="1" fill="hold" nodeType="withEffect">
+                                  <p:stCondLst>
+                                    <p:cond delay="0"/>
+                                  </p:stCondLst>
+                                  <p:childTnLst>
+                                    <p:set>
+                                      <p:cBhvr>
+                                        <p:cTn id="6" dur="1" fill="hold">
+                                          <p:stCondLst>
+                                            <p:cond delay="0"/>
+                                          </p:stCondLst>
+                                        </p:cTn>
+                                        <p:tgtEl>
+                                          <p:spTgt spid="20"/>
+                                        </p:tgtEl>
+                                        <p:attrNameLst>
+                                          <p:attrName>style.visibility</p:attrName>
+                                        </p:attrNameLst>
+                                      </p:cBhvr>
+                                      <p:to>
+                                        <p:strVal val="visible"/>
+                                      </p:to>
+                                    </p:set>
+                                    <p:anim calcmode="lin" valueType="num">
+                                      <p:cBhvr additive="base">
+                                        <p:cTn id="7" dur="250" fill="hold"/>
+                                        <p:tgtEl>
+                                          <p:spTgt spid="20"/>
+                                        </p:tgtEl>
+                                        <p:attrNameLst>
+                                          <p:attrName>ppt_x</p:attrName>
+                                        </p:attrNameLst>
+                                      </p:cBhvr>
+                                      <p:tavLst>
+                                        <p:tav tm="0">
+                                          <p:val>
+                                            <p:strVal val="#ppt_x"/>
+                                          </p:val>
+                                        </p:tav>
+                                        <p:tav tm="100000">
+                                          <p:val>
+                                            <p:strVal val="#ppt_x"/>
+                                          </p:val>
+                                        </p:tav>
+                                      </p:tavLst>
+                                    </p:anim>
+                                    <p:anim calcmode="lin" valueType="num">
+                                      <p:cBhvr additive="base">
+                                        <p:cTn id="8" dur="250" fill="hold"/>
+                                        <p:tgtEl>
+                                          <p:spTgt spid="20"/>
+                                        </p:tgtEl>
+                                        <p:attrNameLst>
+                                          <p:attrName>ppt_y</p:attrName>
+                                        </p:attrNameLst>
+                                      </p:cBhvr>
+                                      <p:tavLst>
+                                        <p:tav tm="0">
+                                          <p:val>
+                                            <p:strVal val="0-#ppt_h/2"/>
+                                          </p:val>
+                                        </p:tav>
+                                        <p:tav tm="100000">
+                                          <p:val>
+                                            <p:strVal val="#ppt_y"/>
+                                          </p:val>
+                                        </p:tav>
+                                      </p:tavLst>
+                                    </p:anim>
+                                  </p:childTnLst>
+                                </p:cTn>
+                              </p:par>
+                              <p:par>
+                                <p:cTn id="9" presetID="2" presetClass="entr" presetSubtype="1" fill="hold" nodeType="withEffect">
+                                  <p:stCondLst>
+                                    <p:cond delay="0"/>
+                                  </p:stCondLst>
+                                  <p:childTnLst>
+                                    <p:set>
+                                      <p:cBhvr>
+                                        <p:cTn id="10" dur="1" fill="hold">
+                                          <p:stCondLst>
+                                            <p:cond delay="0"/>
+                                          </p:stCondLst>
+                                        </p:cTn>
+                                        <p:tgtEl>
+                                          <p:spTgt spid="18"/>
+                                        </p:tgtEl>
+                                        <p:attrNameLst>
+                                          <p:attrName>style.visibility</p:attrName>
+                                        </p:attrNameLst>
+                                      </p:cBhvr>
+                                      <p:to>
+                                        <p:strVal val="visible"/>
+                                      </p:to>
+                                    </p:set>
+                                    <p:anim calcmode="lin" valueType="num">
+                                      <p:cBhvr additive="base">
+                                        <p:cTn id="11" dur="250" fill="hold"/>
+                                        <p:tgtEl>
+                                          <p:spTgt spid="18"/>
+                                        </p:tgtEl>
+                                        <p:attrNameLst>
+                                          <p:attrName>ppt_x</p:attrName>
+                                        </p:attrNameLst>
+                                      </p:cBhvr>
+                                      <p:tavLst>
+                                        <p:tav tm="0">
+                                          <p:val>
+                                            <p:strVal val="#ppt_x"/>
+                                          </p:val>
+                                        </p:tav>
+                                        <p:tav tm="100000">
+                                          <p:val>
+                                            <p:strVal val="#ppt_x"/>
+                                          </p:val>
+                                        </p:tav>
+                                      </p:tavLst>
+                                    </p:anim>
+                                    <p:anim calcmode="lin" valueType="num">
+                                      <p:cBhvr additive="base">
+                                        <p:cTn id="12" dur="250" fill="hold"/>
+                                        <p:tgtEl>
+                                          <p:spTgt spid="18"/>
+                                        </p:tgtEl>
+                                        <p:attrNameLst>
+                                          <p:attrName>ppt_y</p:attrName>
+                                        </p:attrNameLst>
+                                      </p:cBhvr>
+                                      <p:tavLst>
+                                        <p:tav tm="0">
+                                          <p:val>
+                                            <p:strVal val="0-#ppt_h/2"/>
+                                          </p:val>
+                                        </p:tav>
+                                        <p:tav tm="100000">
+                                          <p:val>
+                                            <p:strVal val="#ppt_y"/>
+                                          </p:val>
+                                        </p:tav>
+                                      </p:tavLst>
+                                    </p:anim>
+                                  </p:childTnLst>
+                                </p:cTn>
+                              </p:par>
+                              <p:par>
+                                <p:cTn id="13" presetID="2" presetClass="entr" presetSubtype="1" fill="hold" grpId="0" nodeType="withEffect">
+                                  <p:stCondLst>
+                                    <p:cond delay="0"/>
+                                  </p:stCondLst>
+                                  <p:childTnLst>
+                                    <p:set>
+                                      <p:cBhvr>
+                                        <p:cTn id="14" dur="1" fill="hold">
+                                          <p:stCondLst>
+                                            <p:cond delay="0"/>
+                                          </p:stCondLst>
+                                        </p:cTn>
+                                        <p:tgtEl>
+                                          <p:spTgt spid="15"/>
+                                        </p:tgtEl>
+                                        <p:attrNameLst>
+                                          <p:attrName>style.visibility</p:attrName>
+                                        </p:attrNameLst>
+                                      </p:cBhvr>
+                                      <p:to>
+                                        <p:strVal val="visible"/>
+                                      </p:to>
+                                    </p:set>
+                                    <p:anim calcmode="lin" valueType="num">
+                                      <p:cBhvr additive="base">
+                                        <p:cTn id="15" dur="250" fill="hold"/>
+                                        <p:tgtEl>
+                                          <p:spTgt spid="15"/>
+                                        </p:tgtEl>
+                                        <p:attrNameLst>
+                                          <p:attrName>ppt_x</p:attrName>
+                                        </p:attrNameLst>
+                                      </p:cBhvr>
+                                      <p:tavLst>
+                                        <p:tav tm="0">
+                                          <p:val>
+                                            <p:strVal val="#ppt_x"/>
+                                          </p:val>
+                                        </p:tav>
+                                        <p:tav tm="100000">
+                                          <p:val>
+                                            <p:strVal val="#ppt_x"/>
+                                          </p:val>
+                                        </p:tav>
+                                      </p:tavLst>
+                                    </p:anim>
+                                    <p:anim calcmode="lin" valueType="num">
+                                      <p:cBhvr additive="base">
+                                        <p:cTn id="16" dur="250" fill="hold"/>
+                                        <p:tgtEl>
+                                          <p:spTgt spid="15"/>
+                                        </p:tgtEl>
+                                        <p:attrNameLst>
+                                          <p:attrName>ppt_y</p:attrName>
+                                        </p:attrNameLst>
+                                      </p:cBhvr>
+                                      <p:tavLst>
+                                        <p:tav tm="0">
+                                          <p:val>
+                                            <p:strVal val="0-#ppt_h/2"/>
+                                          </p:val>
+                                        </p:tav>
+                                        <p:tav tm="100000">
+                                          <p:val>
+                                            <p:strVal val="#ppt_y"/>
+                                          </p:val>
+                                        </p:tav>
+                                      </p:tavLst>
+                                    </p:anim>
+                                  </p:childTnLst>
+                                </p:cTn>
+                              </p:par>
+                              <p:par>
+                                <p:cTn id="17" presetID="2" presetClass="entr" presetSubtype="1" fill="hold" grpId="0" nodeType="withEffect">
+                                  <p:stCondLst>
+                                    <p:cond delay="0"/>
+                                  </p:stCondLst>
+                                  <p:childTnLst>
+                                    <p:set>
+                                      <p:cBhvr>
+                                        <p:cTn id="18" dur="1" fill="hold">
+                                          <p:stCondLst>
+                                            <p:cond delay="0"/>
+                                          </p:stCondLst>
+                                        </p:cTn>
+                                        <p:tgtEl>
+                                          <p:spTgt spid="10"/>
+                                        </p:tgtEl>
+                                        <p:attrNameLst>
+                                          <p:attrName>style.visibility</p:attrName>
+                                        </p:attrNameLst>
+                                      </p:cBhvr>
+                                      <p:to>
+                                        <p:strVal val="visible"/>
+                                      </p:to>
+                                    </p:set>
+                                    <p:anim calcmode="lin" valueType="num">
+                                      <p:cBhvr additive="base">
+                                        <p:cTn id="19" dur="250" fill="hold"/>
+                                        <p:tgtEl>
+                                          <p:spTgt spid="10"/>
+                                        </p:tgtEl>
+                                        <p:attrNameLst>
+                                          <p:attrName>ppt_x</p:attrName>
+                                        </p:attrNameLst>
+                                      </p:cBhvr>
+                                      <p:tavLst>
+                                        <p:tav tm="0">
+                                          <p:val>
+                                            <p:strVal val="#ppt_x"/>
+                                          </p:val>
+                                        </p:tav>
+                                        <p:tav tm="100000">
+                                          <p:val>
+                                            <p:strVal val="#ppt_x"/>
+                                          </p:val>
+                                        </p:tav>
+                                      </p:tavLst>
+                                    </p:anim>
+                                    <p:anim calcmode="lin" valueType="num">
+                                      <p:cBhvr additive="base">
+                                        <p:cTn id="20" dur="250" fill="hold"/>
+                                        <p:tgtEl>
+                                          <p:spTgt spid="10"/>
+                                        </p:tgtEl>
+                                        <p:attrNameLst>
+                                          <p:attrName>ppt_y</p:attrName>
+                                        </p:attrNameLst>
+                                      </p:cBhvr>
+                                      <p:tavLst>
+                                        <p:tav tm="0">
+                                          <p:val>
+                                            <p:strVal val="0-#ppt_h/2"/>
+                                          </p:val>
+                                        </p:tav>
+                                        <p:tav tm="100000">
+                                          <p:val>
+                                            <p:strVal val="#ppt_y"/>
+                                          </p:val>
+                                        </p:tav>
+                                      </p:tavLst>
+                                    </p:anim>
+                                  </p:childTnLst>
+                                </p:cTn>
+                              </p:par>
+                            </p:childTnLst>
+                          </p:cTn>
+                        </p:par>
+                      </p:childTnLst>
+                    </p:cTn>
+                  </p:par>
+                </p:childTnLst>
+              </p:cTn>
+              <p:prevCondLst>
+                <p:cond evt="onPrev" delay="0">
+                  <p:tgtEl>
+                    <p:sldTgt/>
+                  </p:tgtEl>
+                </p:cond>
+              </p:prevCondLst>
+              <p:nextCondLst>
+                <p:cond evt="onNext" delay="0">
+                  <p:tgtEl>
+                    <p:sldTgt/>
+                  </p:tgtEl>
+                </p:cond>
+              </p:nextCondLst>
+            </p:seq>
+          </p:childTnLst>
+        </p:cTn>
+      </p:par>
+    </p:tnLst>
+    <p:bldLst>
+      <p:bldP spid="10" grpId="0"/>
+      <p:bldP spid="15" grpId="0"/>
+    </p:bldLst>
+  </p:timing>
 </p:sld>
 </file>
 
 <file path=ppt/slides/slide6.xml><?xml version="1.0" encoding="utf-8"?>
+<p:sld xmlns:a="http://schemas.openxmlformats.org/drawingml/2006/main" xmlns:r="http://schemas.openxmlformats.org/officeDocument/2006/relationships" xmlns:p="http://schemas.openxmlformats.org/presentationml/2006/main">
+  <p:cSld>
+    <p:bg>
+      <p:bgPr>
+        <a:solidFill>
+          <a:srgbClr val="92D050"/>
+        </a:solidFill>
+        <a:effectLst/>
+      </p:bgPr>
+    </p:bg>
+    <p:spTree>
+      <p:nvGrpSpPr>
+        <p:cNvPr id="1" name=""/>
+        <p:cNvGrpSpPr/>
+        <p:nvPr/>
+      </p:nvGrpSpPr>
+      <p:grpSpPr>
+        <a:xfrm>
+          <a:off x="0" y="0"/>
+          <a:ext cx="0" cy="0"/>
+          <a:chOff x="0" y="0"/>
+          <a:chExt cx="0" cy="0"/>
+        </a:xfrm>
+      </p:grpSpPr>
+      <p:sp>
+        <p:nvSpPr>
+          <p:cNvPr id="4" name="Téglalap 3">
+            <a:extLst>
+              <a:ext uri="{FF2B5EF4-FFF2-40B4-BE49-F238E27FC236}">
+                <a16:creationId xmlns:a16="http://schemas.microsoft.com/office/drawing/2014/main" id="{CAA3D94E-F7F3-4698-8A12-46865233ABE2}"/>
+              </a:ext>
+            </a:extLst>
+          </p:cNvPr>
+          <p:cNvSpPr/>
+          <p:nvPr/>
+        </p:nvSpPr>
+        <p:spPr>
+          <a:xfrm>
+            <a:off x="0" y="0"/>
+            <a:ext cx="4461933" cy="6858000"/>
+          </a:xfrm>
+          <a:prstGeom prst="rect">
+            <a:avLst/>
+          </a:prstGeom>
+          <a:solidFill>
+            <a:schemeClr val="tx1">
+              <a:lumMod val="75000"/>
+              <a:lumOff val="25000"/>
+            </a:schemeClr>
+          </a:solidFill>
+          <a:ln>
+            <a:noFill/>
+          </a:ln>
+        </p:spPr>
+        <p:style>
+          <a:lnRef idx="2">
+            <a:schemeClr val="accent1">
+              <a:shade val="50000"/>
+            </a:schemeClr>
+          </a:lnRef>
+          <a:fillRef idx="1">
+            <a:schemeClr val="accent1"/>
+          </a:fillRef>
+          <a:effectRef idx="0">
+            <a:schemeClr val="accent1"/>
+          </a:effectRef>
+          <a:fontRef idx="minor">
+            <a:schemeClr val="lt1"/>
+          </a:fontRef>
+        </p:style>
+        <p:txBody>
+          <a:bodyPr rtlCol="0" anchor="ctr"/>
+          <a:lstStyle/>
+          <a:p>
+            <a:pPr algn="ctr"/>
+            <a:endParaRPr lang="hu-HU"/>
+          </a:p>
+        </p:txBody>
+      </p:sp>
+      <p:sp>
+        <p:nvSpPr>
+          <p:cNvPr id="9" name="Téglalap: lekerekített 8">
+            <a:hlinkClick r:id="rId2" action="ppaction://hlinksldjump"/>
+            <a:extLst>
+              <a:ext uri="{FF2B5EF4-FFF2-40B4-BE49-F238E27FC236}">
+                <a16:creationId xmlns:a16="http://schemas.microsoft.com/office/drawing/2014/main" id="{99B855DB-4288-40FA-8A74-1F91E9D1AAB7}"/>
+              </a:ext>
+            </a:extLst>
+          </p:cNvPr>
+          <p:cNvSpPr/>
+          <p:nvPr/>
+        </p:nvSpPr>
+        <p:spPr>
+          <a:xfrm>
+            <a:off x="119500" y="6435633"/>
+            <a:ext cx="1319833" cy="296333"/>
+          </a:xfrm>
+          <a:prstGeom prst="roundRect">
+            <a:avLst>
+              <a:gd name="adj" fmla="val 50000"/>
+            </a:avLst>
+          </a:prstGeom>
+          <a:solidFill>
+            <a:schemeClr val="bg1">
+              <a:lumMod val="85000"/>
+            </a:schemeClr>
+          </a:solidFill>
+          <a:ln>
+            <a:noFill/>
+          </a:ln>
+        </p:spPr>
+        <p:style>
+          <a:lnRef idx="2">
+            <a:schemeClr val="accent1">
+              <a:shade val="50000"/>
+            </a:schemeClr>
+          </a:lnRef>
+          <a:fillRef idx="1">
+            <a:schemeClr val="accent1"/>
+          </a:fillRef>
+          <a:effectRef idx="0">
+            <a:schemeClr val="accent1"/>
+          </a:effectRef>
+          <a:fontRef idx="minor">
+            <a:schemeClr val="lt1"/>
+          </a:fontRef>
+        </p:style>
+        <p:txBody>
+          <a:bodyPr rtlCol="0" anchor="ctr"/>
+          <a:lstStyle/>
+          <a:p>
+            <a:pPr algn="ctr"/>
+            <a:endParaRPr lang="hu-HU" dirty="0">
+              <a:solidFill>
+                <a:schemeClr val="tx1"/>
+              </a:solidFill>
+              <a:latin typeface="Impact" panose="020B0806030902050204" pitchFamily="34" charset="0"/>
+            </a:endParaRPr>
+          </a:p>
+        </p:txBody>
+      </p:sp>
+      <p:sp>
+        <p:nvSpPr>
+          <p:cNvPr id="2" name="Cím 1">
+            <a:extLst>
+              <a:ext uri="{FF2B5EF4-FFF2-40B4-BE49-F238E27FC236}">
+                <a16:creationId xmlns:a16="http://schemas.microsoft.com/office/drawing/2014/main" id="{C286BF2C-DBCF-49BB-BD4F-7B13369EDF5C}"/>
+              </a:ext>
+            </a:extLst>
+          </p:cNvPr>
+          <p:cNvSpPr>
+            <a:spLocks noGrp="1"/>
+          </p:cNvSpPr>
+          <p:nvPr>
+            <p:ph type="title"/>
+          </p:nvPr>
+        </p:nvSpPr>
+        <p:spPr>
+          <a:xfrm>
+            <a:off x="0" y="221191"/>
+            <a:ext cx="4461933" cy="1325563"/>
+          </a:xfrm>
+        </p:spPr>
+        <p:txBody>
+          <a:bodyPr>
+            <a:normAutofit fontScale="90000"/>
+          </a:bodyPr>
+          <a:lstStyle/>
+          <a:p>
+            <a:pPr algn="ctr"/>
+            <a:r>
+              <a:rPr lang="hu-HU" sz="6000" dirty="0">
+                <a:solidFill>
+                  <a:schemeClr val="bg1"/>
+                </a:solidFill>
+                <a:latin typeface="Impact" panose="020B0806030902050204" pitchFamily="34" charset="0"/>
+              </a:rPr>
+              <a:t>Települések típusai</a:t>
+            </a:r>
+          </a:p>
+        </p:txBody>
+      </p:sp>
+      <p:pic>
+        <p:nvPicPr>
+          <p:cNvPr id="8" name="Kép 7">
+            <a:hlinkClick r:id="rId2" action="ppaction://hlinksldjump"/>
+            <a:extLst>
+              <a:ext uri="{FF2B5EF4-FFF2-40B4-BE49-F238E27FC236}">
+                <a16:creationId xmlns:a16="http://schemas.microsoft.com/office/drawing/2014/main" id="{C3B5158E-4FBF-4266-A73E-ED9BEADC677A}"/>
+              </a:ext>
+            </a:extLst>
+          </p:cNvPr>
+          <p:cNvPicPr>
+            <a:picLocks noChangeAspect="1"/>
+          </p:cNvPicPr>
+          <p:nvPr/>
+        </p:nvPicPr>
+        <p:blipFill>
+          <a:blip r:embed="rId3">
+            <a:extLst>
+              <a:ext uri="{28A0092B-C50C-407E-A947-70E740481C1C}">
+                <a14:useLocalDpi xmlns:a14="http://schemas.microsoft.com/office/drawing/2010/main" val="0"/>
+              </a:ext>
+            </a:extLst>
+          </a:blip>
+          <a:stretch>
+            <a:fillRect/>
+          </a:stretch>
+        </p:blipFill>
+        <p:spPr>
+          <a:xfrm>
+            <a:off x="186268" y="6469016"/>
+            <a:ext cx="229566" cy="229566"/>
+          </a:xfrm>
+          <a:prstGeom prst="rect">
+            <a:avLst/>
+          </a:prstGeom>
+        </p:spPr>
+      </p:pic>
+      <p:sp>
+        <p:nvSpPr>
+          <p:cNvPr id="11" name="Szövegdoboz 10">
+            <a:extLst>
+              <a:ext uri="{FF2B5EF4-FFF2-40B4-BE49-F238E27FC236}">
+                <a16:creationId xmlns:a16="http://schemas.microsoft.com/office/drawing/2014/main" id="{B2C46354-5D08-4490-9E8E-5FDB46852711}"/>
+              </a:ext>
+            </a:extLst>
+          </p:cNvPr>
+          <p:cNvSpPr txBox="1"/>
+          <p:nvPr/>
+        </p:nvSpPr>
+        <p:spPr>
+          <a:xfrm>
+            <a:off x="482602" y="6399133"/>
+            <a:ext cx="879566" cy="369332"/>
+          </a:xfrm>
+          <a:prstGeom prst="rect">
+            <a:avLst/>
+          </a:prstGeom>
+          <a:noFill/>
+        </p:spPr>
+        <p:txBody>
+          <a:bodyPr wrap="square" rtlCol="0">
+            <a:spAutoFit/>
+          </a:bodyPr>
+          <a:lstStyle/>
+          <a:p>
+            <a:r>
+              <a:rPr lang="hu-HU" dirty="0">
+                <a:latin typeface="Impact" panose="020B0806030902050204" pitchFamily="34" charset="0"/>
+                <a:hlinkClick r:id="rId2" action="ppaction://hlinksldjump">
+                  <a:extLst>
+                    <a:ext uri="{A12FA001-AC4F-418D-AE19-62706E023703}">
+                      <ahyp:hlinkClr xmlns:ahyp="http://schemas.microsoft.com/office/drawing/2018/hyperlinkcolor" val="tx"/>
+                    </a:ext>
+                  </a:extLst>
+                </a:hlinkClick>
+              </a:rPr>
+              <a:t>Vissza</a:t>
+            </a:r>
+            <a:endParaRPr lang="hu-HU" dirty="0">
+              <a:latin typeface="Impact" panose="020B0806030902050204" pitchFamily="34" charset="0"/>
+            </a:endParaRPr>
+          </a:p>
+        </p:txBody>
+      </p:sp>
+      <p:cxnSp>
+        <p:nvCxnSpPr>
+          <p:cNvPr id="12" name="Egyenes összekötő 11">
+            <a:extLst>
+              <a:ext uri="{FF2B5EF4-FFF2-40B4-BE49-F238E27FC236}">
+                <a16:creationId xmlns:a16="http://schemas.microsoft.com/office/drawing/2014/main" id="{9AE52744-6B0C-4AA5-84D2-00E216DA312A}"/>
+              </a:ext>
+            </a:extLst>
+          </p:cNvPr>
+          <p:cNvCxnSpPr>
+            <a:cxnSpLocks/>
+          </p:cNvCxnSpPr>
+          <p:nvPr/>
+        </p:nvCxnSpPr>
+        <p:spPr>
+          <a:xfrm>
+            <a:off x="4461933" y="0"/>
+            <a:ext cx="0" cy="6858000"/>
+          </a:xfrm>
+          <a:prstGeom prst="line">
+            <a:avLst/>
+          </a:prstGeom>
+          <a:ln>
+            <a:solidFill>
+              <a:schemeClr val="bg1"/>
+            </a:solidFill>
+          </a:ln>
+        </p:spPr>
+        <p:style>
+          <a:lnRef idx="1">
+            <a:schemeClr val="accent1"/>
+          </a:lnRef>
+          <a:fillRef idx="0">
+            <a:schemeClr val="accent1"/>
+          </a:fillRef>
+          <a:effectRef idx="0">
+            <a:schemeClr val="accent1"/>
+          </a:effectRef>
+          <a:fontRef idx="minor">
+            <a:schemeClr val="tx1"/>
+          </a:fontRef>
+        </p:style>
+      </p:cxnSp>
+      <p:grpSp>
+        <p:nvGrpSpPr>
+          <p:cNvPr id="19" name="Csoportba foglalás 18">
+            <a:extLst>
+              <a:ext uri="{FF2B5EF4-FFF2-40B4-BE49-F238E27FC236}">
+                <a16:creationId xmlns:a16="http://schemas.microsoft.com/office/drawing/2014/main" id="{608A51CC-20E1-B1A4-027B-ED32AA554E18}"/>
+              </a:ext>
+            </a:extLst>
+          </p:cNvPr>
+          <p:cNvGrpSpPr/>
+          <p:nvPr/>
+        </p:nvGrpSpPr>
+        <p:grpSpPr>
+          <a:xfrm>
+            <a:off x="6377931" y="1546754"/>
+            <a:ext cx="3905559" cy="3015734"/>
+            <a:chOff x="6377931" y="1546754"/>
+            <a:chExt cx="3905559" cy="3015734"/>
+          </a:xfrm>
+        </p:grpSpPr>
+        <p:sp>
+          <p:nvSpPr>
+            <p:cNvPr id="5" name="Téglalap 4">
+              <a:extLst>
+                <a:ext uri="{FF2B5EF4-FFF2-40B4-BE49-F238E27FC236}">
+                  <a16:creationId xmlns:a16="http://schemas.microsoft.com/office/drawing/2014/main" id="{546D0B23-CE06-7D40-EE6A-100D539DDEF0}"/>
+                </a:ext>
+              </a:extLst>
+            </p:cNvPr>
+            <p:cNvSpPr/>
+            <p:nvPr/>
+          </p:nvSpPr>
+          <p:spPr>
+            <a:xfrm>
+              <a:off x="6377931" y="1546754"/>
+              <a:ext cx="3905559" cy="591163"/>
+            </a:xfrm>
+            <a:prstGeom prst="rect">
+              <a:avLst/>
+            </a:prstGeom>
+            <a:solidFill>
+              <a:schemeClr val="bg1">
+                <a:lumMod val="75000"/>
+              </a:schemeClr>
+            </a:solidFill>
+          </p:spPr>
+          <p:style>
+            <a:lnRef idx="2">
+              <a:schemeClr val="accent1">
+                <a:shade val="15000"/>
+              </a:schemeClr>
+            </a:lnRef>
+            <a:fillRef idx="1">
+              <a:schemeClr val="accent1"/>
+            </a:fillRef>
+            <a:effectRef idx="0">
+              <a:schemeClr val="accent1"/>
+            </a:effectRef>
+            <a:fontRef idx="minor">
+              <a:schemeClr val="lt1"/>
+            </a:fontRef>
+          </p:style>
+          <p:txBody>
+            <a:bodyPr rtlCol="0" anchor="ctr"/>
+            <a:lstStyle/>
+            <a:p>
+              <a:pPr algn="ctr"/>
+              <a:endParaRPr lang="hu-HU" dirty="0"/>
+            </a:p>
+          </p:txBody>
+        </p:sp>
+        <p:sp>
+          <p:nvSpPr>
+            <p:cNvPr id="7" name="Szövegdoboz 6">
+              <a:extLst>
+                <a:ext uri="{FF2B5EF4-FFF2-40B4-BE49-F238E27FC236}">
+                  <a16:creationId xmlns:a16="http://schemas.microsoft.com/office/drawing/2014/main" id="{87987330-7FA7-9D37-2AD7-53F4E870DD82}"/>
+                </a:ext>
+              </a:extLst>
+            </p:cNvPr>
+            <p:cNvSpPr txBox="1"/>
+            <p:nvPr/>
+          </p:nvSpPr>
+          <p:spPr>
+            <a:xfrm>
+              <a:off x="6933709" y="1606281"/>
+              <a:ext cx="2794000" cy="264267"/>
+            </a:xfrm>
+            <a:prstGeom prst="rect">
+              <a:avLst/>
+            </a:prstGeom>
+            <a:noFill/>
+          </p:spPr>
+          <p:txBody>
+            <a:bodyPr wrap="square" rtlCol="0">
+              <a:spAutoFit/>
+            </a:bodyPr>
+            <a:lstStyle/>
+            <a:p>
+              <a:r>
+                <a:rPr lang="hu-HU" sz="2400" dirty="0">
+                  <a:latin typeface="Arial Black" panose="020B0A04020102020204" pitchFamily="34" charset="0"/>
+                </a:rPr>
+                <a:t>A programban:</a:t>
+              </a:r>
+            </a:p>
+          </p:txBody>
+        </p:sp>
+        <p:pic>
+          <p:nvPicPr>
+            <p:cNvPr id="6" name="Kép 5">
+              <a:extLst>
+                <a:ext uri="{FF2B5EF4-FFF2-40B4-BE49-F238E27FC236}">
+                  <a16:creationId xmlns:a16="http://schemas.microsoft.com/office/drawing/2014/main" id="{56145BCB-1767-26B4-177E-27156A0F747F}"/>
+                </a:ext>
+              </a:extLst>
+            </p:cNvPr>
+            <p:cNvPicPr>
+              <a:picLocks noChangeAspect="1"/>
+            </p:cNvPicPr>
+            <p:nvPr/>
+          </p:nvPicPr>
+          <p:blipFill>
+            <a:blip r:embed="rId4"/>
+            <a:stretch>
+              <a:fillRect/>
+            </a:stretch>
+          </p:blipFill>
+          <p:spPr>
+            <a:xfrm>
+              <a:off x="6377931" y="2144145"/>
+              <a:ext cx="3905558" cy="2418343"/>
+            </a:xfrm>
+            <a:prstGeom prst="rect">
+              <a:avLst/>
+            </a:prstGeom>
+          </p:spPr>
+        </p:pic>
+      </p:grpSp>
+      <p:sp>
+        <p:nvSpPr>
+          <p:cNvPr id="20" name="Szövegdoboz 19">
+            <a:extLst>
+              <a:ext uri="{FF2B5EF4-FFF2-40B4-BE49-F238E27FC236}">
+                <a16:creationId xmlns:a16="http://schemas.microsoft.com/office/drawing/2014/main" id="{A0B34673-FAA0-0C4B-6FDA-72A48D57AC6A}"/>
+              </a:ext>
+            </a:extLst>
+          </p:cNvPr>
+          <p:cNvSpPr txBox="1"/>
+          <p:nvPr/>
+        </p:nvSpPr>
+        <p:spPr>
+          <a:xfrm>
+            <a:off x="4944535" y="622300"/>
+            <a:ext cx="6993464" cy="646331"/>
+          </a:xfrm>
+          <a:prstGeom prst="rect">
+            <a:avLst/>
+          </a:prstGeom>
+          <a:noFill/>
+        </p:spPr>
+        <p:txBody>
+          <a:bodyPr wrap="square" rtlCol="0">
+            <a:spAutoFit/>
+          </a:bodyPr>
+          <a:lstStyle/>
+          <a:p>
+            <a:r>
+              <a:rPr lang="hu-HU" sz="3600" dirty="0">
+                <a:latin typeface="Arial Black" panose="020B0A04020102020204" pitchFamily="34" charset="0"/>
+              </a:rPr>
+              <a:t>Ilyen formában megjelenik</a:t>
+            </a:r>
+          </a:p>
+        </p:txBody>
+      </p:sp>
+      <p:sp>
+        <p:nvSpPr>
+          <p:cNvPr id="21" name="Szövegdoboz 20">
+            <a:extLst>
+              <a:ext uri="{FF2B5EF4-FFF2-40B4-BE49-F238E27FC236}">
+                <a16:creationId xmlns:a16="http://schemas.microsoft.com/office/drawing/2014/main" id="{55CA5D15-A18A-B6DC-A3C5-ED4A436584E4}"/>
+              </a:ext>
+            </a:extLst>
+          </p:cNvPr>
+          <p:cNvSpPr txBox="1"/>
+          <p:nvPr/>
+        </p:nvSpPr>
+        <p:spPr>
+          <a:xfrm>
+            <a:off x="4944535" y="4720084"/>
+            <a:ext cx="6693884" cy="400110"/>
+          </a:xfrm>
+          <a:prstGeom prst="rect">
+            <a:avLst/>
+          </a:prstGeom>
+          <a:noFill/>
+        </p:spPr>
+        <p:txBody>
+          <a:bodyPr wrap="none" rtlCol="0">
+            <a:spAutoFit/>
+          </a:bodyPr>
+          <a:lstStyle/>
+          <a:p>
+            <a:r>
+              <a:rPr lang="hu-HU" sz="2000" dirty="0" err="1">
+                <a:latin typeface="Arial Black" panose="020B0A04020102020204" pitchFamily="34" charset="0"/>
+              </a:rPr>
+              <a:t>Responsive</a:t>
+            </a:r>
+            <a:r>
+              <a:rPr lang="hu-HU" sz="2000" dirty="0">
+                <a:latin typeface="Arial Black" panose="020B0A04020102020204" pitchFamily="34" charset="0"/>
+              </a:rPr>
+              <a:t> az összes terminál mérettel mivel:</a:t>
+            </a:r>
+          </a:p>
+        </p:txBody>
+      </p:sp>
+      <p:pic>
+        <p:nvPicPr>
+          <p:cNvPr id="23" name="Kép 22">
+            <a:extLst>
+              <a:ext uri="{FF2B5EF4-FFF2-40B4-BE49-F238E27FC236}">
+                <a16:creationId xmlns:a16="http://schemas.microsoft.com/office/drawing/2014/main" id="{E73EC96D-7776-A913-7CD6-D526B305A925}"/>
+              </a:ext>
+            </a:extLst>
+          </p:cNvPr>
+          <p:cNvPicPr>
+            <a:picLocks noChangeAspect="1"/>
+          </p:cNvPicPr>
+          <p:nvPr/>
+        </p:nvPicPr>
+        <p:blipFill>
+          <a:blip r:embed="rId5"/>
+          <a:stretch>
+            <a:fillRect/>
+          </a:stretch>
+        </p:blipFill>
+        <p:spPr>
+          <a:xfrm>
+            <a:off x="4819521" y="5311246"/>
+            <a:ext cx="6943912" cy="646331"/>
+          </a:xfrm>
+          <a:prstGeom prst="rect">
+            <a:avLst/>
+          </a:prstGeom>
+        </p:spPr>
+      </p:pic>
+    </p:spTree>
+    <p:extLst>
+      <p:ext uri="{BB962C8B-B14F-4D97-AF65-F5344CB8AC3E}">
+        <p14:creationId xmlns:p14="http://schemas.microsoft.com/office/powerpoint/2010/main" val="92460414"/>
+      </p:ext>
+    </p:extLst>
+  </p:cSld>
+  <p:clrMapOvr>
+    <a:masterClrMapping/>
+  </p:clrMapOvr>
+  <p:transition spd="slow">
+    <p:push dir="u"/>
+  </p:transition>
+  <p:timing>
+    <p:tnLst>
+      <p:par>
+        <p:cTn id="1" dur="indefinite" restart="never" nodeType="tmRoot">
+          <p:childTnLst>
+            <p:seq concurrent="1" nextAc="seek">
+              <p:cTn id="2" dur="indefinite" nodeType="mainSeq">
+                <p:childTnLst>
+                  <p:par>
+                    <p:cTn id="3" fill="hold">
+                      <p:stCondLst>
+                        <p:cond delay="indefinite"/>
+                        <p:cond evt="onBegin" delay="0">
+                          <p:tn val="2"/>
+                        </p:cond>
+                      </p:stCondLst>
+                      <p:childTnLst>
+                        <p:par>
+                          <p:cTn id="4" fill="hold">
+                            <p:stCondLst>
+                              <p:cond delay="0"/>
+                            </p:stCondLst>
+                            <p:childTnLst>
+                              <p:par>
+                                <p:cTn id="5" presetID="2" presetClass="entr" presetSubtype="1" fill="hold" grpId="0" nodeType="withEffect">
+                                  <p:stCondLst>
+                                    <p:cond delay="0"/>
+                                  </p:stCondLst>
+                                  <p:childTnLst>
+                                    <p:set>
+                                      <p:cBhvr>
+                                        <p:cTn id="6" dur="1" fill="hold">
+                                          <p:stCondLst>
+                                            <p:cond delay="0"/>
+                                          </p:stCondLst>
+                                        </p:cTn>
+                                        <p:tgtEl>
+                                          <p:spTgt spid="20"/>
+                                        </p:tgtEl>
+                                        <p:attrNameLst>
+                                          <p:attrName>style.visibility</p:attrName>
+                                        </p:attrNameLst>
+                                      </p:cBhvr>
+                                      <p:to>
+                                        <p:strVal val="visible"/>
+                                      </p:to>
+                                    </p:set>
+                                    <p:anim calcmode="lin" valueType="num">
+                                      <p:cBhvr additive="base">
+                                        <p:cTn id="7" dur="250" fill="hold"/>
+                                        <p:tgtEl>
+                                          <p:spTgt spid="20"/>
+                                        </p:tgtEl>
+                                        <p:attrNameLst>
+                                          <p:attrName>ppt_x</p:attrName>
+                                        </p:attrNameLst>
+                                      </p:cBhvr>
+                                      <p:tavLst>
+                                        <p:tav tm="0">
+                                          <p:val>
+                                            <p:strVal val="#ppt_x"/>
+                                          </p:val>
+                                        </p:tav>
+                                        <p:tav tm="100000">
+                                          <p:val>
+                                            <p:strVal val="#ppt_x"/>
+                                          </p:val>
+                                        </p:tav>
+                                      </p:tavLst>
+                                    </p:anim>
+                                    <p:anim calcmode="lin" valueType="num">
+                                      <p:cBhvr additive="base">
+                                        <p:cTn id="8" dur="250" fill="hold"/>
+                                        <p:tgtEl>
+                                          <p:spTgt spid="20"/>
+                                        </p:tgtEl>
+                                        <p:attrNameLst>
+                                          <p:attrName>ppt_y</p:attrName>
+                                        </p:attrNameLst>
+                                      </p:cBhvr>
+                                      <p:tavLst>
+                                        <p:tav tm="0">
+                                          <p:val>
+                                            <p:strVal val="0-#ppt_h/2"/>
+                                          </p:val>
+                                        </p:tav>
+                                        <p:tav tm="100000">
+                                          <p:val>
+                                            <p:strVal val="#ppt_y"/>
+                                          </p:val>
+                                        </p:tav>
+                                      </p:tavLst>
+                                    </p:anim>
+                                  </p:childTnLst>
+                                </p:cTn>
+                              </p:par>
+                              <p:par>
+                                <p:cTn id="9" presetID="2" presetClass="entr" presetSubtype="1" fill="hold" nodeType="withEffect">
+                                  <p:stCondLst>
+                                    <p:cond delay="0"/>
+                                  </p:stCondLst>
+                                  <p:childTnLst>
+                                    <p:set>
+                                      <p:cBhvr>
+                                        <p:cTn id="10" dur="1" fill="hold">
+                                          <p:stCondLst>
+                                            <p:cond delay="0"/>
+                                          </p:stCondLst>
+                                        </p:cTn>
+                                        <p:tgtEl>
+                                          <p:spTgt spid="19"/>
+                                        </p:tgtEl>
+                                        <p:attrNameLst>
+                                          <p:attrName>style.visibility</p:attrName>
+                                        </p:attrNameLst>
+                                      </p:cBhvr>
+                                      <p:to>
+                                        <p:strVal val="visible"/>
+                                      </p:to>
+                                    </p:set>
+                                    <p:anim calcmode="lin" valueType="num">
+                                      <p:cBhvr additive="base">
+                                        <p:cTn id="11" dur="250" fill="hold"/>
+                                        <p:tgtEl>
+                                          <p:spTgt spid="19"/>
+                                        </p:tgtEl>
+                                        <p:attrNameLst>
+                                          <p:attrName>ppt_x</p:attrName>
+                                        </p:attrNameLst>
+                                      </p:cBhvr>
+                                      <p:tavLst>
+                                        <p:tav tm="0">
+                                          <p:val>
+                                            <p:strVal val="#ppt_x"/>
+                                          </p:val>
+                                        </p:tav>
+                                        <p:tav tm="100000">
+                                          <p:val>
+                                            <p:strVal val="#ppt_x"/>
+                                          </p:val>
+                                        </p:tav>
+                                      </p:tavLst>
+                                    </p:anim>
+                                    <p:anim calcmode="lin" valueType="num">
+                                      <p:cBhvr additive="base">
+                                        <p:cTn id="12" dur="250" fill="hold"/>
+                                        <p:tgtEl>
+                                          <p:spTgt spid="19"/>
+                                        </p:tgtEl>
+                                        <p:attrNameLst>
+                                          <p:attrName>ppt_y</p:attrName>
+                                        </p:attrNameLst>
+                                      </p:cBhvr>
+                                      <p:tavLst>
+                                        <p:tav tm="0">
+                                          <p:val>
+                                            <p:strVal val="0-#ppt_h/2"/>
+                                          </p:val>
+                                        </p:tav>
+                                        <p:tav tm="100000">
+                                          <p:val>
+                                            <p:strVal val="#ppt_y"/>
+                                          </p:val>
+                                        </p:tav>
+                                      </p:tavLst>
+                                    </p:anim>
+                                  </p:childTnLst>
+                                </p:cTn>
+                              </p:par>
+                              <p:par>
+                                <p:cTn id="13" presetID="2" presetClass="entr" presetSubtype="1" fill="hold" grpId="0" nodeType="withEffect">
+                                  <p:stCondLst>
+                                    <p:cond delay="0"/>
+                                  </p:stCondLst>
+                                  <p:childTnLst>
+                                    <p:set>
+                                      <p:cBhvr>
+                                        <p:cTn id="14" dur="1" fill="hold">
+                                          <p:stCondLst>
+                                            <p:cond delay="0"/>
+                                          </p:stCondLst>
+                                        </p:cTn>
+                                        <p:tgtEl>
+                                          <p:spTgt spid="21"/>
+                                        </p:tgtEl>
+                                        <p:attrNameLst>
+                                          <p:attrName>style.visibility</p:attrName>
+                                        </p:attrNameLst>
+                                      </p:cBhvr>
+                                      <p:to>
+                                        <p:strVal val="visible"/>
+                                      </p:to>
+                                    </p:set>
+                                    <p:anim calcmode="lin" valueType="num">
+                                      <p:cBhvr additive="base">
+                                        <p:cTn id="15" dur="250" fill="hold"/>
+                                        <p:tgtEl>
+                                          <p:spTgt spid="21"/>
+                                        </p:tgtEl>
+                                        <p:attrNameLst>
+                                          <p:attrName>ppt_x</p:attrName>
+                                        </p:attrNameLst>
+                                      </p:cBhvr>
+                                      <p:tavLst>
+                                        <p:tav tm="0">
+                                          <p:val>
+                                            <p:strVal val="#ppt_x"/>
+                                          </p:val>
+                                        </p:tav>
+                                        <p:tav tm="100000">
+                                          <p:val>
+                                            <p:strVal val="#ppt_x"/>
+                                          </p:val>
+                                        </p:tav>
+                                      </p:tavLst>
+                                    </p:anim>
+                                    <p:anim calcmode="lin" valueType="num">
+                                      <p:cBhvr additive="base">
+                                        <p:cTn id="16" dur="250" fill="hold"/>
+                                        <p:tgtEl>
+                                          <p:spTgt spid="21"/>
+                                        </p:tgtEl>
+                                        <p:attrNameLst>
+                                          <p:attrName>ppt_y</p:attrName>
+                                        </p:attrNameLst>
+                                      </p:cBhvr>
+                                      <p:tavLst>
+                                        <p:tav tm="0">
+                                          <p:val>
+                                            <p:strVal val="0-#ppt_h/2"/>
+                                          </p:val>
+                                        </p:tav>
+                                        <p:tav tm="100000">
+                                          <p:val>
+                                            <p:strVal val="#ppt_y"/>
+                                          </p:val>
+                                        </p:tav>
+                                      </p:tavLst>
+                                    </p:anim>
+                                  </p:childTnLst>
+                                </p:cTn>
+                              </p:par>
+                              <p:par>
+                                <p:cTn id="17" presetID="2" presetClass="entr" presetSubtype="1" fill="hold" nodeType="withEffect">
+                                  <p:stCondLst>
+                                    <p:cond delay="0"/>
+                                  </p:stCondLst>
+                                  <p:childTnLst>
+                                    <p:set>
+                                      <p:cBhvr>
+                                        <p:cTn id="18" dur="1" fill="hold">
+                                          <p:stCondLst>
+                                            <p:cond delay="0"/>
+                                          </p:stCondLst>
+                                        </p:cTn>
+                                        <p:tgtEl>
+                                          <p:spTgt spid="23"/>
+                                        </p:tgtEl>
+                                        <p:attrNameLst>
+                                          <p:attrName>style.visibility</p:attrName>
+                                        </p:attrNameLst>
+                                      </p:cBhvr>
+                                      <p:to>
+                                        <p:strVal val="visible"/>
+                                      </p:to>
+                                    </p:set>
+                                    <p:anim calcmode="lin" valueType="num">
+                                      <p:cBhvr additive="base">
+                                        <p:cTn id="19" dur="250" fill="hold"/>
+                                        <p:tgtEl>
+                                          <p:spTgt spid="23"/>
+                                        </p:tgtEl>
+                                        <p:attrNameLst>
+                                          <p:attrName>ppt_x</p:attrName>
+                                        </p:attrNameLst>
+                                      </p:cBhvr>
+                                      <p:tavLst>
+                                        <p:tav tm="0">
+                                          <p:val>
+                                            <p:strVal val="#ppt_x"/>
+                                          </p:val>
+                                        </p:tav>
+                                        <p:tav tm="100000">
+                                          <p:val>
+                                            <p:strVal val="#ppt_x"/>
+                                          </p:val>
+                                        </p:tav>
+                                      </p:tavLst>
+                                    </p:anim>
+                                    <p:anim calcmode="lin" valueType="num">
+                                      <p:cBhvr additive="base">
+                                        <p:cTn id="20" dur="250" fill="hold"/>
+                                        <p:tgtEl>
+                                          <p:spTgt spid="23"/>
+                                        </p:tgtEl>
+                                        <p:attrNameLst>
+                                          <p:attrName>ppt_y</p:attrName>
+                                        </p:attrNameLst>
+                                      </p:cBhvr>
+                                      <p:tavLst>
+                                        <p:tav tm="0">
+                                          <p:val>
+                                            <p:strVal val="0-#ppt_h/2"/>
+                                          </p:val>
+                                        </p:tav>
+                                        <p:tav tm="100000">
+                                          <p:val>
+                                            <p:strVal val="#ppt_y"/>
+                                          </p:val>
+                                        </p:tav>
+                                      </p:tavLst>
+                                    </p:anim>
+                                  </p:childTnLst>
+                                </p:cTn>
+                              </p:par>
+                            </p:childTnLst>
+                          </p:cTn>
+                        </p:par>
+                      </p:childTnLst>
+                    </p:cTn>
+                  </p:par>
+                </p:childTnLst>
+              </p:cTn>
+              <p:prevCondLst>
+                <p:cond evt="onPrev" delay="0">
+                  <p:tgtEl>
+                    <p:sldTgt/>
+                  </p:tgtEl>
+                </p:cond>
+              </p:prevCondLst>
+              <p:nextCondLst>
+                <p:cond evt="onNext" delay="0">
+                  <p:tgtEl>
+                    <p:sldTgt/>
+                  </p:tgtEl>
+                </p:cond>
+              </p:nextCondLst>
+            </p:seq>
+          </p:childTnLst>
+        </p:cTn>
+      </p:par>
+    </p:tnLst>
+    <p:bldLst>
+      <p:bldP spid="20" grpId="0"/>
+      <p:bldP spid="21" grpId="0"/>
+    </p:bldLst>
+  </p:timing>
+</p:sld>
+</file>
+
+<file path=ppt/slides/slide7.xml><?xml version="1.0" encoding="utf-8"?>
 <p:sld xmlns:a="http://schemas.openxmlformats.org/drawingml/2006/main" xmlns:r="http://schemas.openxmlformats.org/officeDocument/2006/relationships" xmlns:p="http://schemas.openxmlformats.org/presentationml/2006/main">
   <p:cSld>
     <p:bg>

</xml_diff>